<commit_message>
Add verified company signup and invitation onboarding
</commit_message>
<xml_diff>
--- a/docs/presentations/BidXchange-How-To-Use.pptx
+++ b/docs/presentations/BidXchange-How-To-Use.pptx
@@ -525,7 +525,7 @@
           <a:p>
             <a:r>
               <a:rPr lang="en-US" dirty="0"/>
-              <a:t>Allow 25–30 minutes plus practice. This guide follows the deployed contractor workflow, release 0107d2c, September 21, 2026. Open https://bidxapp.vercel.app/. Screenshots are public fictional demo data. Use an authorized training workspace for changes; the public demo does not reproduce every authenticated feature.</a:t>
+              <a:t>Allow 25–30 minutes plus practice. This guide follows the deployed contractor workflow, including company signup and invitations, September 21, 2026. Open https://bidxapp.vercel.app/. Screenshots are public fictional demo data. Use an authorized training workspace for changes; the public demo does not reproduce every authenticated feature.</a:t>
             </a:r>
             <a:endParaRPr lang="en-US" dirty="0"/>
           </a:p>
@@ -2021,7 +2021,7 @@
           <a:p>
             <a:r>
               <a:rPr lang="en-US" dirty="0"/>
-              <a:t>Account provisioning and organization membership are currently managed; do not promise self-service organization creation. Never share credentials. Users with several companies must check the selected organization on every task. A missing button may reflect their role.</a:t>
+              <a:t>Company creation and joining are under /onboarding. Administrators create invitations in Settings → Create and manage team invitations, then share the join address themselves. No invitation email is sent automatically. Invitations last seven days and require the exact confirmed email. Existing active roles are preserved. Creating a company saves workspace names but does not attest Passport evidence. Each account can create up to three companies; contact support for more. Never share sign-in links or codes. Users with several companies must confirm the selected organization on every task.</a:t>
             </a:r>
             <a:endParaRPr lang="en-US" dirty="0"/>
           </a:p>
@@ -16029,7 +16029,7 @@
                 <a:ea typeface="Aptos" pitchFamily="34" charset="-122"/>
                 <a:cs typeface="Aptos" pitchFamily="34" charset="-120"/>
               </a:rPr>
-              <a:t>Sign in and confirm your company</a:t>
+              <a:t>Create or join your company</a:t>
             </a:r>
             <a:endParaRPr lang="en-US" sz="3000" dirty="0"/>
           </a:p>
@@ -16161,7 +16161,7 @@
                 <a:ea typeface="Aptos" pitchFamily="34" charset="-122"/>
                 <a:cs typeface="Aptos" pitchFamily="34" charset="-120"/>
               </a:rPr>
-              <a:t>Use your own account</a:t>
+              <a:t>Confirm your work email</a:t>
             </a:r>
             <a:endParaRPr lang="en-US" sz="2200" dirty="0"/>
           </a:p>
@@ -16200,7 +16200,7 @@
                 <a:ea typeface="Aptos" pitchFamily="34" charset="-122"/>
                 <a:cs typeface="Aptos" pitchFamily="34" charset="-120"/>
               </a:rPr>
-              <a:t>Open bidxapp.vercel.app and sign in using your work email and the sign-in instructions.</a:t>
+              <a:t>Open /signup for a new account or /login to sign in. Use the confirmation link or email code.</a:t>
             </a:r>
             <a:endParaRPr lang="en-US" sz="1800" dirty="0"/>
           </a:p>
@@ -16332,7 +16332,7 @@
                 <a:ea typeface="Aptos" pitchFamily="34" charset="-122"/>
                 <a:cs typeface="Aptos" pitchFamily="34" charset="-120"/>
               </a:rPr>
-              <a:t>Check the workspace</a:t>
+              <a:t>Create or accept an invitation</a:t>
             </a:r>
             <a:endParaRPr lang="en-US" sz="2200" dirty="0"/>
           </a:p>
@@ -16371,7 +16371,7 @@
                 <a:ea typeface="Aptos" pitchFamily="34" charset="-122"/>
                 <a:cs typeface="Aptos" pitchFamily="34" charset="-120"/>
               </a:rPr>
-              <a:t>Confirm the selected company before entering evidence, researching a bid or creating a draft.</a:t>
+              <a:t>Open /onboarding. Create a company you administer, or accept the invitation for your exact confirmed email.</a:t>
             </a:r>
             <a:endParaRPr lang="en-US" sz="1800" dirty="0"/>
           </a:p>
@@ -16503,7 +16503,7 @@
                 <a:ea typeface="Aptos" pitchFamily="34" charset="-122"/>
                 <a:cs typeface="Aptos" pitchFamily="34" charset="-120"/>
               </a:rPr>
-              <a:t>If you cannot enter</a:t>
+              <a:t>Follow the setup checklist</a:t>
             </a:r>
             <a:endParaRPr lang="en-US" sz="2200" dirty="0"/>
           </a:p>
@@ -16542,7 +16542,7 @@
                 <a:ea typeface="Aptos" pitchFamily="34" charset="-122"/>
                 <a:cs typeface="Aptos" pitchFamily="34" charset="-120"/>
               </a:rPr>
-              <a:t>An account needs active organization membership. Ask the workspace administrator to arrange access.</a:t>
+              <a:t>Open each Passport area, save supported evidence, then record your first opportunity. Confirm the selected company.</a:t>
             </a:r>
             <a:endParaRPr lang="en-US" sz="1800" dirty="0"/>
           </a:p>

</xml_diff>

<commit_message>
Connect fictional bid rehearsal and refresh training and outcome records
</commit_message>
<xml_diff>
--- a/docs/presentations/BidXchange-How-To-Use.pptx
+++ b/docs/presentations/BidXchange-How-To-Use.pptx
@@ -29,9 +29,11 @@
     <p:sldId id="277" r:id="rId23"/>
     <p:sldId id="278" r:id="rId24"/>
     <p:sldId id="279" r:id="rId25"/>
+    <p:sldId id="280" r:id="rId26"/>
+    <p:sldId id="281" r:id="rId27"/>
   </p:sldIdLst>
   <p:notesMasterIdLst>
-    <p:notesMasterId r:id="rId26"/>
+    <p:notesMasterId r:id="rId28"/>
   </p:notesMasterIdLst>
   <p:sldSz cx="12192000" cy="6858000"/>
   <p:notesSz cx="6858000" cy="12192000"/>
@@ -525,7 +527,7 @@
           <a:p>
             <a:r>
               <a:rPr lang="en-US" dirty="0"/>
-              <a:t>Allow 25–30 minutes plus practice. This guide follows the deployed contractor workflow, including company signup and invitations, September 21, 2026. Open https://bidxapp.vercel.app/. Screenshots are public fictional demo data. Use an authorized training workspace for changes; the public demo does not reproduce every authenticated feature.</a:t>
+              <a:t>Allow 25–30 minutes plus practice. This guide follows the deployed contractor workflow, including company signup and invitations, September 22, 2026. Open https://bidxapp.vercel.app/. Screenshots are public fictional demo data. Use an authorized training workspace for changes; the public demo does not reproduce every authenticated feature.</a:t>
             </a:r>
             <a:endParaRPr lang="en-US" dirty="0"/>
           </a:p>
@@ -1669,7 +1671,7 @@
           <a:p>
             <a:r>
               <a:rPr lang="en-US" dirty="0"/>
-              <a:t>The amendment review control asks you to type reviewed. That acknowledgment does not automatically sign off the register. Expired/stale linked evidence can also reopen review when a pursuit is opened. There is no background email notification. Context includes a UTC review-date boundary, so next-day work can require renewed review.</a:t>
+              <a:t>The amendment review control asks you to type reviewed. That acknowledgment does not automatically sign off the register. Expired or stale linked evidence can reopen review through the scheduled monitor or pursuit access. Check in-app reminders; no email or SMS notification is sent. Context includes a UTC review-date boundary, so next-day work can require renewed review.</a:t>
             </a:r>
             <a:endParaRPr lang="en-US" dirty="0"/>
           </a:p>
@@ -1757,7 +1759,7 @@
           <a:p>
             <a:r>
               <a:rPr lang="en-US" dirty="0"/>
-              <a:t>Do not promise automatic award detection or outcome-to-past-performance promotion; the complete promotion workflow is still unfinished. Estimator and viewer privileges differ from approver privileges. Do not borrow an account to bypass a missing permission. The same person may hold several authorized responsibilities; strict four-person separation is not enforced.</a:t>
+              <a:t>Outcome details are saved in existing follow-up history. Leave unofficial awardee/amount unknown. Permission to disclose defaults to not granted and is available for recorded awards only. An award is not completed past performance; reuse is never automatic. The full outcome-to-past-performance promotion workflow remains unfinished. Estimator and viewer privileges differ from approver privileges. Do not borrow an account to bypass a missing permission. The same person may hold several authorized responsibilities; strict four-person separation is not enforced.</a:t>
             </a:r>
             <a:endParaRPr lang="en-US" dirty="0"/>
           </a:p>
@@ -1975,6 +1977,182 @@
 </p:notes>
 </file>
 
+<file path=ppt/notesSlides/notesSlide25.xml><?xml version="1.0" encoding="utf-8"?>
+<p:notes xmlns:a="http://schemas.openxmlformats.org/drawingml/2006/main" xmlns:r="http://schemas.openxmlformats.org/officeDocument/2006/relationships" xmlns:p="http://schemas.openxmlformats.org/presentationml/2006/main">
+  <p:cSld>
+    <p:spTree>
+      <p:nvGrpSpPr>
+        <p:cNvPr id="1" name=""/>
+        <p:cNvGrpSpPr/>
+        <p:nvPr/>
+      </p:nvGrpSpPr>
+      <p:grpSpPr>
+        <a:xfrm>
+          <a:off x="0" y="0"/>
+          <a:ext cx="0" cy="0"/>
+          <a:chOff x="0" y="0"/>
+          <a:chExt cx="0" cy="0"/>
+        </a:xfrm>
+      </p:grpSpPr>
+      <p:sp>
+        <p:nvSpPr>
+          <p:cNvPr id="2" name="Slide Image Placeholder 1"/>
+          <p:cNvSpPr>
+            <a:spLocks noGrp="1" noRot="1" noChangeAspect="1"/>
+          </p:cNvSpPr>
+          <p:nvPr>
+            <p:ph type="sldImg"/>
+          </p:nvPr>
+        </p:nvSpPr>
+        <p:spPr/>
+      </p:sp>
+      <p:sp>
+        <p:nvSpPr>
+          <p:cNvPr id="3" name="Notes Placeholder 2"/>
+          <p:cNvSpPr>
+            <a:spLocks noGrp="1"/>
+          </p:cNvSpPr>
+          <p:nvPr>
+            <p:ph type="body" idx="1"/>
+          </p:nvPr>
+        </p:nvSpPr>
+        <p:spPr/>
+        <p:txBody>
+          <a:bodyPr/>
+          <a:lstStyle/>
+          <a:p>
+            <a:r>
+              <a:rPr lang="en-US" dirty="0"/>
+              <a:t>The checklist uses the selected pursuit, not another opportunity. An administrator or executive approver signs off the Requirements Register. Missing sign-off is not treated as current. The source, review, decision and release controls remain subject to role permissions.</a:t>
+            </a:r>
+            <a:endParaRPr lang="en-US" dirty="0"/>
+          </a:p>
+        </p:txBody>
+      </p:sp>
+      <p:sp>
+        <p:nvSpPr>
+          <p:cNvPr id="4" name="Slide Number Placeholder 3"/>
+          <p:cNvSpPr>
+            <a:spLocks noGrp="1"/>
+          </p:cNvSpPr>
+          <p:nvPr>
+            <p:ph type="sldNum" sz="quarter" idx="10"/>
+          </p:nvPr>
+        </p:nvSpPr>
+        <p:spPr/>
+        <p:txBody>
+          <a:bodyPr/>
+          <a:lstStyle/>
+          <a:p>
+            <a:fld id="{F7021451-1387-4CA6-816F-3879F97B5CBC}" type="slidenum">
+              <a:rPr lang="en-US"/>
+              <a:t>25</a:t>
+            </a:fld>
+            <a:endParaRPr lang="en-US"/>
+          </a:p>
+        </p:txBody>
+      </p:sp>
+    </p:spTree>
+    <p:extLst>
+      <p:ext uri="{BB962C8B-B14F-4D97-AF65-F5344CB8AC3E}">
+        <p14:creationId xmlns:p14="http://schemas.microsoft.com/office/powerpoint/2010/main" val="1024086991"/>
+      </p:ext>
+    </p:extLst>
+  </p:cSld>
+  <p:clrMapOvr>
+    <a:masterClrMapping/>
+  </p:clrMapOvr>
+</p:notes>
+</file>
+
+<file path=ppt/notesSlides/notesSlide26.xml><?xml version="1.0" encoding="utf-8"?>
+<p:notes xmlns:a="http://schemas.openxmlformats.org/drawingml/2006/main" xmlns:r="http://schemas.openxmlformats.org/officeDocument/2006/relationships" xmlns:p="http://schemas.openxmlformats.org/presentationml/2006/main">
+  <p:cSld>
+    <p:spTree>
+      <p:nvGrpSpPr>
+        <p:cNvPr id="1" name=""/>
+        <p:cNvGrpSpPr/>
+        <p:nvPr/>
+      </p:nvGrpSpPr>
+      <p:grpSpPr>
+        <a:xfrm>
+          <a:off x="0" y="0"/>
+          <a:ext cx="0" cy="0"/>
+          <a:chOff x="0" y="0"/>
+          <a:chExt cx="0" cy="0"/>
+        </a:xfrm>
+      </p:grpSpPr>
+      <p:sp>
+        <p:nvSpPr>
+          <p:cNvPr id="2" name="Slide Image Placeholder 1"/>
+          <p:cNvSpPr>
+            <a:spLocks noGrp="1" noRot="1" noChangeAspect="1"/>
+          </p:cNvSpPr>
+          <p:nvPr>
+            <p:ph type="sldImg"/>
+          </p:nvPr>
+        </p:nvSpPr>
+        <p:spPr/>
+      </p:sp>
+      <p:sp>
+        <p:nvSpPr>
+          <p:cNvPr id="3" name="Notes Placeholder 2"/>
+          <p:cNvSpPr>
+            <a:spLocks noGrp="1"/>
+          </p:cNvSpPr>
+          <p:nvPr>
+            <p:ph type="body" idx="1"/>
+          </p:nvPr>
+        </p:nvSpPr>
+        <p:spPr/>
+        <p:txBody>
+          <a:bodyPr/>
+          <a:lstStyle/>
+          <a:p>
+            <a:r>
+              <a:rPr lang="en-US" dirty="0"/>
+              <a:t>Open /pursuits/DEMO-001?workspace=demo. Use only made-up text. Exercise state resets on leaving or reload. The training export is text; real authenticated response exports support PDF and Word. No-bid prevents advancement in the exercise. Editing a draft clears its approval. Amendment and insurance-expiration controls make the decision stale and prevent reuse of the old approval. Historical events remain visible until reset. This rehearsal is not proof of production permissions or a real submission.</a:t>
+            </a:r>
+            <a:endParaRPr lang="en-US" dirty="0"/>
+          </a:p>
+        </p:txBody>
+      </p:sp>
+      <p:sp>
+        <p:nvSpPr>
+          <p:cNvPr id="4" name="Slide Number Placeholder 3"/>
+          <p:cNvSpPr>
+            <a:spLocks noGrp="1"/>
+          </p:cNvSpPr>
+          <p:nvPr>
+            <p:ph type="sldNum" sz="quarter" idx="10"/>
+          </p:nvPr>
+        </p:nvSpPr>
+        <p:spPr/>
+        <p:txBody>
+          <a:bodyPr/>
+          <a:lstStyle/>
+          <a:p>
+            <a:fld id="{F7021451-1387-4CA6-816F-3879F97B5CBC}" type="slidenum">
+              <a:rPr lang="en-US"/>
+              <a:t>26</a:t>
+            </a:fld>
+            <a:endParaRPr lang="en-US"/>
+          </a:p>
+        </p:txBody>
+      </p:sp>
+    </p:spTree>
+    <p:extLst>
+      <p:ext uri="{BB962C8B-B14F-4D97-AF65-F5344CB8AC3E}">
+        <p14:creationId xmlns:p14="http://schemas.microsoft.com/office/powerpoint/2010/main" val="1024086991"/>
+      </p:ext>
+    </p:extLst>
+  </p:cSld>
+  <p:clrMapOvr>
+    <a:masterClrMapping/>
+  </p:clrMapOvr>
+</p:notes>
+</file>
+
 <file path=ppt/notesSlides/notesSlide3.xml><?xml version="1.0" encoding="utf-8"?>
 <p:notes xmlns:a="http://schemas.openxmlformats.org/drawingml/2006/main" xmlns:r="http://schemas.openxmlformats.org/officeDocument/2006/relationships" xmlns:p="http://schemas.openxmlformats.org/presentationml/2006/main">
   <p:cSld>
@@ -2373,7 +2551,7 @@
           <a:p>
             <a:r>
               <a:rPr lang="en-US" dirty="0"/>
-              <a:t>The source-check date falls back to the attestation date when no explicit check date exists. Stale means last checked over 90 days ago. Follow-up creation runs on pursuit access; there is no background email notification. Previous decisions remain in history. Restricted records may be hidden from the current role.</a:t>
+              <a:t>The source-check date falls back to the attestation date when no explicit check date exists. Stale means last checked over 90 days ago. A scheduled monitor checks enabled organizations once per UTC day, processed in batches. Opening a pursuit also checks linked evidence. In-app reminders appear in Today and Company. Acknowledging a reminder does not renew evidence or clear a blocker. No email or SMS notification is sent. Previous decisions remain in history. Restricted records may be hidden from the current role.</a:t>
             </a:r>
             <a:endParaRPr lang="en-US" dirty="0"/>
           </a:p>
@@ -13818,7 +13996,7 @@
                 <a:ea typeface="Aptos" pitchFamily="34" charset="-122"/>
                 <a:cs typeface="Aptos" pitchFamily="34" charset="-120"/>
               </a:rPr>
-              <a:t>Use release follow-up for questions, clarification, award/loss, cancellation, debrief and lessons learned.</a:t>
+              <a:t>Open Post-submission follow-up. Record an award, loss or cancellation with date, official source, reason and debrief.</a:t>
             </a:r>
             <a:endParaRPr lang="en-US" sz="1800" dirty="0"/>
           </a:p>
@@ -15906,6 +16084,1594 @@
 </p:sld>
 </file>
 
+<file path=ppt/slides/slide25.xml><?xml version="1.0" encoding="utf-8"?>
+<p:sld xmlns:a="http://schemas.openxmlformats.org/drawingml/2006/main" xmlns:r="http://schemas.openxmlformats.org/officeDocument/2006/relationships" xmlns:p="http://schemas.openxmlformats.org/presentationml/2006/main">
+  <p:cSld name="Slide 25">
+    <p:bg>
+      <p:bgPr>
+        <a:solidFill>
+          <a:srgbClr val="F3F6FB"/>
+        </a:solidFill>
+      </p:bgPr>
+    </p:bg>
+    <p:spTree>
+      <p:nvGrpSpPr>
+        <p:cNvPr id="1" name=""/>
+        <p:cNvGrpSpPr/>
+        <p:nvPr/>
+      </p:nvGrpSpPr>
+      <p:grpSpPr>
+        <a:xfrm>
+          <a:off x="0" y="0"/>
+          <a:ext cx="0" cy="0"/>
+          <a:chOff x="0" y="0"/>
+          <a:chExt cx="0" cy="0"/>
+        </a:xfrm>
+      </p:grpSpPr>
+      <p:sp>
+        <p:nvSpPr>
+          <p:cNvPr id="3" name="Shape 0"/>
+          <p:cNvSpPr/>
+          <p:nvPr/>
+        </p:nvSpPr>
+        <p:spPr>
+          <a:xfrm>
+            <a:off x="0" y="0"/>
+            <a:ext cx="12191695" cy="82296"/>
+          </a:xfrm>
+          <a:prstGeom prst="rect">
+            <a:avLst/>
+          </a:prstGeom>
+          <a:solidFill>
+            <a:srgbClr val="235AF5"/>
+          </a:solidFill>
+          <a:ln w="12700">
+            <a:solidFill>
+              <a:srgbClr val="235AF5">
+                <a:alpha val="0"/>
+              </a:srgbClr>
+            </a:solidFill>
+            <a:prstDash val="solid"/>
+          </a:ln>
+        </p:spPr>
+      </p:sp>
+      <p:sp>
+        <p:nvSpPr>
+          <p:cNvPr id="4" name="Text 1"/>
+          <p:cNvSpPr/>
+          <p:nvPr/>
+        </p:nvSpPr>
+        <p:spPr>
+          <a:xfrm>
+            <a:off x="594360" y="347472"/>
+            <a:ext cx="10058400" cy="274320"/>
+          </a:xfrm>
+          <a:prstGeom prst="rect">
+            <a:avLst/>
+          </a:prstGeom>
+          <a:noFill/>
+          <a:ln/>
+        </p:spPr>
+        <p:txBody>
+          <a:bodyPr wrap="square" lIns="0" tIns="0" rIns="0" bIns="0" rtlCol="0" anchor="t"/>
+          <a:lstStyle/>
+          <a:p>
+            <a:pPr indent="0" marL="0">
+              <a:buNone/>
+            </a:pPr>
+            <a:r>
+              <a:rPr lang="en-US" sz="1200" b="1" dirty="0">
+                <a:solidFill>
+                  <a:srgbClr val="235AF5"/>
+                </a:solidFill>
+                <a:latin typeface="Aptos" pitchFamily="34" charset="0"/>
+                <a:ea typeface="Aptos" pitchFamily="34" charset="-122"/>
+                <a:cs typeface="Aptos" pitchFamily="34" charset="-120"/>
+              </a:rPr>
+              <a:t>WORKSPACE GUIDE</a:t>
+            </a:r>
+            <a:endParaRPr lang="en-US" sz="1200" dirty="0"/>
+          </a:p>
+        </p:txBody>
+      </p:sp>
+      <p:sp>
+        <p:nvSpPr>
+          <p:cNvPr id="5" name="Text 2"/>
+          <p:cNvSpPr/>
+          <p:nvPr/>
+        </p:nvSpPr>
+        <p:spPr>
+          <a:xfrm>
+            <a:off x="594360" y="850392"/>
+            <a:ext cx="11018520" cy="731520"/>
+          </a:xfrm>
+          <a:prstGeom prst="rect">
+            <a:avLst/>
+          </a:prstGeom>
+          <a:noFill/>
+          <a:ln/>
+        </p:spPr>
+        <p:txBody>
+          <a:bodyPr wrap="square" lIns="0" tIns="0" rIns="0" bIns="0" rtlCol="0" anchor="t"/>
+          <a:lstStyle/>
+          <a:p>
+            <a:pPr indent="0" marL="0">
+              <a:buNone/>
+            </a:pPr>
+            <a:r>
+              <a:rPr lang="en-US" sz="3000" b="1" dirty="0">
+                <a:solidFill>
+                  <a:srgbClr val="0D1933"/>
+                </a:solidFill>
+                <a:latin typeface="Aptos" pitchFamily="34" charset="0"/>
+                <a:ea typeface="Aptos" pitchFamily="34" charset="-122"/>
+                <a:cs typeface="Aptos" pitchFamily="34" charset="-120"/>
+              </a:rPr>
+              <a:t>Use the thirteen-step pursuit checklist</a:t>
+            </a:r>
+            <a:endParaRPr lang="en-US" sz="3000" dirty="0"/>
+          </a:p>
+        </p:txBody>
+      </p:sp>
+      <p:sp>
+        <p:nvSpPr>
+          <p:cNvPr id="6" name="Shape 3"/>
+          <p:cNvSpPr/>
+          <p:nvPr/>
+        </p:nvSpPr>
+        <p:spPr>
+          <a:xfrm>
+            <a:off x="594360" y="1856232"/>
+            <a:ext cx="3520440" cy="3557016"/>
+          </a:xfrm>
+          <a:prstGeom prst="rect">
+            <a:avLst/>
+          </a:prstGeom>
+          <a:solidFill>
+            <a:srgbClr val="FFFFFF"/>
+          </a:solidFill>
+          <a:ln w="12700">
+            <a:solidFill>
+              <a:srgbClr val="FFFFFF">
+                <a:alpha val="0"/>
+              </a:srgbClr>
+            </a:solidFill>
+            <a:prstDash val="solid"/>
+          </a:ln>
+        </p:spPr>
+      </p:sp>
+      <p:sp>
+        <p:nvSpPr>
+          <p:cNvPr id="7" name="Shape 4"/>
+          <p:cNvSpPr/>
+          <p:nvPr/>
+        </p:nvSpPr>
+        <p:spPr>
+          <a:xfrm>
+            <a:off x="594360" y="1856232"/>
+            <a:ext cx="54864" cy="3557016"/>
+          </a:xfrm>
+          <a:prstGeom prst="rect">
+            <a:avLst/>
+          </a:prstGeom>
+          <a:solidFill>
+            <a:srgbClr val="235AF5"/>
+          </a:solidFill>
+          <a:ln w="12700">
+            <a:solidFill>
+              <a:srgbClr val="235AF5">
+                <a:alpha val="0"/>
+              </a:srgbClr>
+            </a:solidFill>
+            <a:prstDash val="solid"/>
+          </a:ln>
+        </p:spPr>
+      </p:sp>
+      <p:sp>
+        <p:nvSpPr>
+          <p:cNvPr id="8" name="Text 5"/>
+          <p:cNvSpPr/>
+          <p:nvPr/>
+        </p:nvSpPr>
+        <p:spPr>
+          <a:xfrm>
+            <a:off x="804672" y="2057400"/>
+            <a:ext cx="3017520" cy="365760"/>
+          </a:xfrm>
+          <a:prstGeom prst="rect">
+            <a:avLst/>
+          </a:prstGeom>
+          <a:noFill/>
+          <a:ln/>
+        </p:spPr>
+        <p:txBody>
+          <a:bodyPr wrap="square" lIns="0" tIns="0" rIns="0" bIns="0" rtlCol="0" anchor="t"/>
+          <a:lstStyle/>
+          <a:p>
+            <a:pPr indent="0" marL="0">
+              <a:buNone/>
+            </a:pPr>
+            <a:r>
+              <a:rPr lang="en-US" sz="1300" b="1" dirty="0">
+                <a:solidFill>
+                  <a:srgbClr val="235AF5"/>
+                </a:solidFill>
+                <a:latin typeface="Aptos" pitchFamily="34" charset="0"/>
+                <a:ea typeface="Aptos" pitchFamily="34" charset="-122"/>
+                <a:cs typeface="Aptos" pitchFamily="34" charset="-120"/>
+              </a:rPr>
+              <a:t>01</a:t>
+            </a:r>
+            <a:endParaRPr lang="en-US" sz="1300" dirty="0"/>
+          </a:p>
+        </p:txBody>
+      </p:sp>
+      <p:sp>
+        <p:nvSpPr>
+          <p:cNvPr id="9" name="Text 6"/>
+          <p:cNvSpPr/>
+          <p:nvPr/>
+        </p:nvSpPr>
+        <p:spPr>
+          <a:xfrm>
+            <a:off x="804672" y="2587752"/>
+            <a:ext cx="3072384" cy="731520"/>
+          </a:xfrm>
+          <a:prstGeom prst="rect">
+            <a:avLst/>
+          </a:prstGeom>
+          <a:noFill/>
+          <a:ln/>
+        </p:spPr>
+        <p:txBody>
+          <a:bodyPr wrap="square" lIns="0" tIns="0" rIns="0" bIns="0" rtlCol="0" anchor="t"/>
+          <a:lstStyle/>
+          <a:p>
+            <a:pPr indent="0" marL="0">
+              <a:buNone/>
+            </a:pPr>
+            <a:r>
+              <a:rPr lang="en-US" sz="2200" b="1" dirty="0">
+                <a:solidFill>
+                  <a:srgbClr val="0D1933"/>
+                </a:solidFill>
+                <a:latin typeface="Aptos" pitchFamily="34" charset="0"/>
+                <a:ea typeface="Aptos" pitchFamily="34" charset="-122"/>
+                <a:cs typeface="Aptos" pitchFamily="34" charset="-120"/>
+              </a:rPr>
+              <a:t>Open it inside a pursuit</a:t>
+            </a:r>
+            <a:endParaRPr lang="en-US" sz="2200" dirty="0"/>
+          </a:p>
+        </p:txBody>
+      </p:sp>
+      <p:sp>
+        <p:nvSpPr>
+          <p:cNvPr id="10" name="Text 7"/>
+          <p:cNvSpPr/>
+          <p:nvPr/>
+        </p:nvSpPr>
+        <p:spPr>
+          <a:xfrm>
+            <a:off x="804672" y="3465576"/>
+            <a:ext cx="3035808" cy="1673352"/>
+          </a:xfrm>
+          <a:prstGeom prst="rect">
+            <a:avLst/>
+          </a:prstGeom>
+          <a:noFill/>
+          <a:ln/>
+        </p:spPr>
+        <p:txBody>
+          <a:bodyPr wrap="square" lIns="0" tIns="0" rIns="0" bIns="0" rtlCol="0" anchor="t"/>
+          <a:lstStyle/>
+          <a:p>
+            <a:pPr indent="0" marL="0">
+              <a:buNone/>
+            </a:pPr>
+            <a:r>
+              <a:rPr lang="en-US" sz="1800" dirty="0">
+                <a:solidFill>
+                  <a:srgbClr val="172641"/>
+                </a:solidFill>
+                <a:latin typeface="Aptos" pitchFamily="34" charset="0"/>
+                <a:ea typeface="Aptos" pitchFamily="34" charset="-122"/>
+                <a:cs typeface="Aptos" pitchFamily="34" charset="-120"/>
+              </a:rPr>
+              <a:t>Choose ?Open this pursuit?s workflow checklist.? Each step links to the relevant record or control.</a:t>
+            </a:r>
+            <a:endParaRPr lang="en-US" sz="1800" dirty="0"/>
+          </a:p>
+        </p:txBody>
+      </p:sp>
+      <p:sp>
+        <p:nvSpPr>
+          <p:cNvPr id="11" name="Shape 8"/>
+          <p:cNvSpPr/>
+          <p:nvPr/>
+        </p:nvSpPr>
+        <p:spPr>
+          <a:xfrm>
+            <a:off x="4343400" y="1856232"/>
+            <a:ext cx="3520440" cy="3557016"/>
+          </a:xfrm>
+          <a:prstGeom prst="rect">
+            <a:avLst/>
+          </a:prstGeom>
+          <a:solidFill>
+            <a:srgbClr val="FFFFFF"/>
+          </a:solidFill>
+          <a:ln w="12700">
+            <a:solidFill>
+              <a:srgbClr val="FFFFFF">
+                <a:alpha val="0"/>
+              </a:srgbClr>
+            </a:solidFill>
+            <a:prstDash val="solid"/>
+          </a:ln>
+        </p:spPr>
+      </p:sp>
+      <p:sp>
+        <p:nvSpPr>
+          <p:cNvPr id="12" name="Shape 9"/>
+          <p:cNvSpPr/>
+          <p:nvPr/>
+        </p:nvSpPr>
+        <p:spPr>
+          <a:xfrm>
+            <a:off x="4343400" y="1856232"/>
+            <a:ext cx="54864" cy="3557016"/>
+          </a:xfrm>
+          <a:prstGeom prst="rect">
+            <a:avLst/>
+          </a:prstGeom>
+          <a:solidFill>
+            <a:srgbClr val="F2B337"/>
+          </a:solidFill>
+          <a:ln w="12700">
+            <a:solidFill>
+              <a:srgbClr val="F2B337">
+                <a:alpha val="0"/>
+              </a:srgbClr>
+            </a:solidFill>
+            <a:prstDash val="solid"/>
+          </a:ln>
+        </p:spPr>
+      </p:sp>
+      <p:sp>
+        <p:nvSpPr>
+          <p:cNvPr id="13" name="Text 10"/>
+          <p:cNvSpPr/>
+          <p:nvPr/>
+        </p:nvSpPr>
+        <p:spPr>
+          <a:xfrm>
+            <a:off x="4553712" y="2057400"/>
+            <a:ext cx="3017520" cy="365760"/>
+          </a:xfrm>
+          <a:prstGeom prst="rect">
+            <a:avLst/>
+          </a:prstGeom>
+          <a:noFill/>
+          <a:ln/>
+        </p:spPr>
+        <p:txBody>
+          <a:bodyPr wrap="square" lIns="0" tIns="0" rIns="0" bIns="0" rtlCol="0" anchor="t"/>
+          <a:lstStyle/>
+          <a:p>
+            <a:pPr indent="0" marL="0">
+              <a:buNone/>
+            </a:pPr>
+            <a:r>
+              <a:rPr lang="en-US" sz="1300" b="1" dirty="0">
+                <a:solidFill>
+                  <a:srgbClr val="235AF5"/>
+                </a:solidFill>
+                <a:latin typeface="Aptos" pitchFamily="34" charset="0"/>
+                <a:ea typeface="Aptos" pitchFamily="34" charset="-122"/>
+                <a:cs typeface="Aptos" pitchFamily="34" charset="-120"/>
+              </a:rPr>
+              <a:t>02</a:t>
+            </a:r>
+            <a:endParaRPr lang="en-US" sz="1300" dirty="0"/>
+          </a:p>
+        </p:txBody>
+      </p:sp>
+      <p:sp>
+        <p:nvSpPr>
+          <p:cNvPr id="14" name="Text 11"/>
+          <p:cNvSpPr/>
+          <p:nvPr/>
+        </p:nvSpPr>
+        <p:spPr>
+          <a:xfrm>
+            <a:off x="4553712" y="2587752"/>
+            <a:ext cx="3072384" cy="731520"/>
+          </a:xfrm>
+          <a:prstGeom prst="rect">
+            <a:avLst/>
+          </a:prstGeom>
+          <a:noFill/>
+          <a:ln/>
+        </p:spPr>
+        <p:txBody>
+          <a:bodyPr wrap="square" lIns="0" tIns="0" rIns="0" bIns="0" rtlCol="0" anchor="t"/>
+          <a:lstStyle/>
+          <a:p>
+            <a:pPr indent="0" marL="0">
+              <a:buNone/>
+            </a:pPr>
+            <a:r>
+              <a:rPr lang="en-US" sz="2200" b="1" dirty="0">
+                <a:solidFill>
+                  <a:srgbClr val="0D1933"/>
+                </a:solidFill>
+                <a:latin typeface="Aptos" pitchFamily="34" charset="0"/>
+                <a:ea typeface="Aptos" pitchFamily="34" charset="-122"/>
+                <a:cs typeface="Aptos" pitchFamily="34" charset="-120"/>
+              </a:rPr>
+              <a:t>Follow the current records</a:t>
+            </a:r>
+            <a:endParaRPr lang="en-US" sz="2200" dirty="0"/>
+          </a:p>
+        </p:txBody>
+      </p:sp>
+      <p:sp>
+        <p:nvSpPr>
+          <p:cNvPr id="15" name="Text 12"/>
+          <p:cNvSpPr/>
+          <p:nvPr/>
+        </p:nvSpPr>
+        <p:spPr>
+          <a:xfrm>
+            <a:off x="4553712" y="3465576"/>
+            <a:ext cx="3035808" cy="1673352"/>
+          </a:xfrm>
+          <a:prstGeom prst="rect">
+            <a:avLst/>
+          </a:prstGeom>
+          <a:noFill/>
+          <a:ln/>
+        </p:spPr>
+        <p:txBody>
+          <a:bodyPr wrap="square" lIns="0" tIns="0" rIns="0" bIns="0" rtlCol="0" anchor="t"/>
+          <a:lstStyle/>
+          <a:p>
+            <a:pPr indent="0" marL="0">
+              <a:buNone/>
+            </a:pPr>
+            <a:r>
+              <a:rPr lang="en-US" sz="1800" dirty="0">
+                <a:solidFill>
+                  <a:srgbClr val="172641"/>
+                </a:solidFill>
+                <a:latin typeface="Aptos" pitchFamily="34" charset="0"/>
+                <a:ea typeface="Aptos" pitchFamily="34" charset="-122"/>
+                <a:cs typeface="Aptos" pitchFamily="34" charset="-120"/>
+              </a:rPr>
+              <a:t>Requirements sign-off comes before a final bid/no-bid decision. A current no-bid stops response recommendations.</a:t>
+            </a:r>
+            <a:endParaRPr lang="en-US" sz="1800" dirty="0"/>
+          </a:p>
+        </p:txBody>
+      </p:sp>
+      <p:sp>
+        <p:nvSpPr>
+          <p:cNvPr id="16" name="Shape 13"/>
+          <p:cNvSpPr/>
+          <p:nvPr/>
+        </p:nvSpPr>
+        <p:spPr>
+          <a:xfrm>
+            <a:off x="8092440" y="1856232"/>
+            <a:ext cx="3520440" cy="3557016"/>
+          </a:xfrm>
+          <a:prstGeom prst="rect">
+            <a:avLst/>
+          </a:prstGeom>
+          <a:solidFill>
+            <a:srgbClr val="FFFFFF"/>
+          </a:solidFill>
+          <a:ln w="12700">
+            <a:solidFill>
+              <a:srgbClr val="FFFFFF">
+                <a:alpha val="0"/>
+              </a:srgbClr>
+            </a:solidFill>
+            <a:prstDash val="solid"/>
+          </a:ln>
+        </p:spPr>
+      </p:sp>
+      <p:sp>
+        <p:nvSpPr>
+          <p:cNvPr id="17" name="Shape 14"/>
+          <p:cNvSpPr/>
+          <p:nvPr/>
+        </p:nvSpPr>
+        <p:spPr>
+          <a:xfrm>
+            <a:off x="8092440" y="1856232"/>
+            <a:ext cx="54864" cy="3557016"/>
+          </a:xfrm>
+          <a:prstGeom prst="rect">
+            <a:avLst/>
+          </a:prstGeom>
+          <a:solidFill>
+            <a:srgbClr val="235AF5"/>
+          </a:solidFill>
+          <a:ln w="12700">
+            <a:solidFill>
+              <a:srgbClr val="235AF5">
+                <a:alpha val="0"/>
+              </a:srgbClr>
+            </a:solidFill>
+            <a:prstDash val="solid"/>
+          </a:ln>
+        </p:spPr>
+      </p:sp>
+      <p:sp>
+        <p:nvSpPr>
+          <p:cNvPr id="18" name="Text 15"/>
+          <p:cNvSpPr/>
+          <p:nvPr/>
+        </p:nvSpPr>
+        <p:spPr>
+          <a:xfrm>
+            <a:off x="8302752" y="2057400"/>
+            <a:ext cx="3017520" cy="365760"/>
+          </a:xfrm>
+          <a:prstGeom prst="rect">
+            <a:avLst/>
+          </a:prstGeom>
+          <a:noFill/>
+          <a:ln/>
+        </p:spPr>
+        <p:txBody>
+          <a:bodyPr wrap="square" lIns="0" tIns="0" rIns="0" bIns="0" rtlCol="0" anchor="t"/>
+          <a:lstStyle/>
+          <a:p>
+            <a:pPr indent="0" marL="0">
+              <a:buNone/>
+            </a:pPr>
+            <a:r>
+              <a:rPr lang="en-US" sz="1300" b="1" dirty="0">
+                <a:solidFill>
+                  <a:srgbClr val="235AF5"/>
+                </a:solidFill>
+                <a:latin typeface="Aptos" pitchFamily="34" charset="0"/>
+                <a:ea typeface="Aptos" pitchFamily="34" charset="-122"/>
+                <a:cs typeface="Aptos" pitchFamily="34" charset="-120"/>
+              </a:rPr>
+              <a:t>03</a:t>
+            </a:r>
+            <a:endParaRPr lang="en-US" sz="1300" dirty="0"/>
+          </a:p>
+        </p:txBody>
+      </p:sp>
+      <p:sp>
+        <p:nvSpPr>
+          <p:cNvPr id="19" name="Text 16"/>
+          <p:cNvSpPr/>
+          <p:nvPr/>
+        </p:nvSpPr>
+        <p:spPr>
+          <a:xfrm>
+            <a:off x="8302752" y="2587752"/>
+            <a:ext cx="3072384" cy="731520"/>
+          </a:xfrm>
+          <a:prstGeom prst="rect">
+            <a:avLst/>
+          </a:prstGeom>
+          <a:noFill/>
+          <a:ln/>
+        </p:spPr>
+        <p:txBody>
+          <a:bodyPr wrap="square" lIns="0" tIns="0" rIns="0" bIns="0" rtlCol="0" anchor="t"/>
+          <a:lstStyle/>
+          <a:p>
+            <a:pPr indent="0" marL="0">
+              <a:buNone/>
+            </a:pPr>
+            <a:r>
+              <a:rPr lang="en-US" sz="2200" b="1" dirty="0">
+                <a:solidFill>
+                  <a:srgbClr val="0D1933"/>
+                </a:solidFill>
+                <a:latin typeface="Aptos" pitchFamily="34" charset="0"/>
+                <a:ea typeface="Aptos" pitchFamily="34" charset="-122"/>
+                <a:cs typeface="Aptos" pitchFamily="34" charset="-120"/>
+              </a:rPr>
+              <a:t>Read the status carefully</a:t>
+            </a:r>
+            <a:endParaRPr lang="en-US" sz="2200" dirty="0"/>
+          </a:p>
+        </p:txBody>
+      </p:sp>
+      <p:sp>
+        <p:nvSpPr>
+          <p:cNvPr id="20" name="Text 17"/>
+          <p:cNvSpPr/>
+          <p:nvPr/>
+        </p:nvSpPr>
+        <p:spPr>
+          <a:xfrm>
+            <a:off x="8302752" y="3465576"/>
+            <a:ext cx="3035808" cy="1673352"/>
+          </a:xfrm>
+          <a:prstGeom prst="rect">
+            <a:avLst/>
+          </a:prstGeom>
+          <a:noFill/>
+          <a:ln/>
+        </p:spPr>
+        <p:txBody>
+          <a:bodyPr wrap="square" lIns="0" tIns="0" rIns="0" bIns="0" rtlCol="0" anchor="t"/>
+          <a:lstStyle/>
+          <a:p>
+            <a:pPr indent="0" marL="0">
+              <a:buNone/>
+            </a:pPr>
+            <a:r>
+              <a:rPr lang="en-US" sz="1800" dirty="0">
+                <a:solidFill>
+                  <a:srgbClr val="172641"/>
+                </a:solidFill>
+                <a:latin typeface="Aptos" pitchFamily="34" charset="0"/>
+                <a:ea typeface="Aptos" pitchFamily="34" charset="-122"/>
+                <a:cs typeface="Aptos" pitchFamily="34" charset="-120"/>
+              </a:rPr>
+              <a:t>Recorded means a saved record exists. It does not mean eligible, compliant or submitted by BidXchange.</a:t>
+            </a:r>
+            <a:endParaRPr lang="en-US" sz="1800" dirty="0"/>
+          </a:p>
+        </p:txBody>
+      </p:sp>
+      <p:sp>
+        <p:nvSpPr>
+          <p:cNvPr id="21" name="Shape 18"/>
+          <p:cNvSpPr/>
+          <p:nvPr/>
+        </p:nvSpPr>
+        <p:spPr>
+          <a:xfrm>
+            <a:off x="594360" y="5650992"/>
+            <a:ext cx="11018520" cy="576072"/>
+          </a:xfrm>
+          <a:prstGeom prst="rect">
+            <a:avLst/>
+          </a:prstGeom>
+          <a:solidFill>
+            <a:srgbClr val="0D1933"/>
+          </a:solidFill>
+          <a:ln w="12700">
+            <a:solidFill>
+              <a:srgbClr val="0D1933">
+                <a:alpha val="0"/>
+              </a:srgbClr>
+            </a:solidFill>
+            <a:prstDash val="solid"/>
+          </a:ln>
+        </p:spPr>
+      </p:sp>
+      <p:sp>
+        <p:nvSpPr>
+          <p:cNvPr id="22" name="Text 19"/>
+          <p:cNvSpPr/>
+          <p:nvPr/>
+        </p:nvSpPr>
+        <p:spPr>
+          <a:xfrm>
+            <a:off x="777240" y="5779008"/>
+            <a:ext cx="10607040" cy="374904"/>
+          </a:xfrm>
+          <a:prstGeom prst="rect">
+            <a:avLst/>
+          </a:prstGeom>
+          <a:noFill/>
+          <a:ln/>
+        </p:spPr>
+        <p:txBody>
+          <a:bodyPr wrap="square" lIns="0" tIns="0" rIns="0" bIns="0" rtlCol="0" anchor="t"/>
+          <a:lstStyle/>
+          <a:p>
+            <a:pPr indent="0" marL="0">
+              <a:buNone/>
+            </a:pPr>
+            <a:r>
+              <a:rPr lang="en-US" sz="1400" dirty="0">
+                <a:solidFill>
+                  <a:srgbClr val="FFFFFF"/>
+                </a:solidFill>
+                <a:latin typeface="Aptos" pitchFamily="34" charset="0"/>
+                <a:ea typeface="Aptos" pitchFamily="34" charset="-122"/>
+                <a:cs typeface="Aptos" pitchFamily="34" charset="-120"/>
+              </a:rPr>
+              <a:t>A changed source or evidence record can require renewed human review.</a:t>
+            </a:r>
+            <a:endParaRPr lang="en-US" sz="1400" dirty="0"/>
+          </a:p>
+        </p:txBody>
+      </p:sp>
+      <p:sp>
+        <p:nvSpPr>
+          <p:cNvPr id="23" name="Text 20"/>
+          <p:cNvSpPr/>
+          <p:nvPr/>
+        </p:nvSpPr>
+        <p:spPr>
+          <a:xfrm>
+            <a:off x="594360" y="6510528"/>
+            <a:ext cx="9144000" cy="182880"/>
+          </a:xfrm>
+          <a:prstGeom prst="rect">
+            <a:avLst/>
+          </a:prstGeom>
+          <a:noFill/>
+          <a:ln/>
+        </p:spPr>
+        <p:txBody>
+          <a:bodyPr wrap="square" lIns="0" tIns="0" rIns="0" bIns="0" rtlCol="0" anchor="t"/>
+          <a:lstStyle/>
+          <a:p>
+            <a:pPr indent="0" marL="0">
+              <a:buNone/>
+            </a:pPr>
+            <a:r>
+              <a:rPr lang="en-US" sz="900" dirty="0">
+                <a:solidFill>
+                  <a:srgbClr val="506178"/>
+                </a:solidFill>
+                <a:latin typeface="Aptos" pitchFamily="34" charset="0"/>
+                <a:ea typeface="Aptos" pitchFamily="34" charset="-122"/>
+                <a:cs typeface="Aptos" pitchFamily="34" charset="-120"/>
+              </a:rPr>
+              <a:t>BidXchange  /  HOW TO USE THE APP</a:t>
+            </a:r>
+            <a:endParaRPr lang="en-US" sz="900" dirty="0"/>
+          </a:p>
+        </p:txBody>
+      </p:sp>
+      <p:sp>
+        <p:nvSpPr>
+          <p:cNvPr id="24" name="Text 21"/>
+          <p:cNvSpPr/>
+          <p:nvPr/>
+        </p:nvSpPr>
+        <p:spPr>
+          <a:xfrm>
+            <a:off x="11000232" y="6473952"/>
+            <a:ext cx="594360" cy="246888"/>
+          </a:xfrm>
+          <a:prstGeom prst="rect">
+            <a:avLst/>
+          </a:prstGeom>
+          <a:noFill/>
+          <a:ln/>
+        </p:spPr>
+        <p:txBody>
+          <a:bodyPr wrap="square" lIns="0" tIns="0" rIns="0" bIns="0" rtlCol="0" anchor="t"/>
+          <a:lstStyle/>
+          <a:p>
+            <a:pPr algn="r" indent="0" marL="0">
+              <a:buNone/>
+            </a:pPr>
+            <a:r>
+              <a:rPr lang="en-US" sz="1100" dirty="0">
+                <a:solidFill>
+                  <a:srgbClr val="506178"/>
+                </a:solidFill>
+                <a:latin typeface="Aptos" pitchFamily="34" charset="0"/>
+                <a:ea typeface="Aptos" pitchFamily="34" charset="-122"/>
+                <a:cs typeface="Aptos" pitchFamily="34" charset="-120"/>
+              </a:rPr>
+              <a:t>25</a:t>
+            </a:r>
+            <a:endParaRPr lang="en-US" sz="1100" dirty="0"/>
+          </a:p>
+        </p:txBody>
+      </p:sp>
+    </p:spTree>
+  </p:cSld>
+  <p:clrMapOvr>
+    <a:masterClrMapping/>
+  </p:clrMapOvr>
+</p:sld>
+</file>
+
+<file path=ppt/slides/slide26.xml><?xml version="1.0" encoding="utf-8"?>
+<p:sld xmlns:a="http://schemas.openxmlformats.org/drawingml/2006/main" xmlns:r="http://schemas.openxmlformats.org/officeDocument/2006/relationships" xmlns:p="http://schemas.openxmlformats.org/presentationml/2006/main">
+  <p:cSld name="Slide 26">
+    <p:bg>
+      <p:bgPr>
+        <a:solidFill>
+          <a:srgbClr val="F3F6FB"/>
+        </a:solidFill>
+      </p:bgPr>
+    </p:bg>
+    <p:spTree>
+      <p:nvGrpSpPr>
+        <p:cNvPr id="1" name=""/>
+        <p:cNvGrpSpPr/>
+        <p:nvPr/>
+      </p:nvGrpSpPr>
+      <p:grpSpPr>
+        <a:xfrm>
+          <a:off x="0" y="0"/>
+          <a:ext cx="0" cy="0"/>
+          <a:chOff x="0" y="0"/>
+          <a:chExt cx="0" cy="0"/>
+        </a:xfrm>
+      </p:grpSpPr>
+      <p:sp>
+        <p:nvSpPr>
+          <p:cNvPr id="3" name="Shape 0"/>
+          <p:cNvSpPr/>
+          <p:nvPr/>
+        </p:nvSpPr>
+        <p:spPr>
+          <a:xfrm>
+            <a:off x="0" y="0"/>
+            <a:ext cx="12191695" cy="82296"/>
+          </a:xfrm>
+          <a:prstGeom prst="rect">
+            <a:avLst/>
+          </a:prstGeom>
+          <a:solidFill>
+            <a:srgbClr val="235AF5"/>
+          </a:solidFill>
+          <a:ln w="12700">
+            <a:solidFill>
+              <a:srgbClr val="235AF5">
+                <a:alpha val="0"/>
+              </a:srgbClr>
+            </a:solidFill>
+            <a:prstDash val="solid"/>
+          </a:ln>
+        </p:spPr>
+      </p:sp>
+      <p:sp>
+        <p:nvSpPr>
+          <p:cNvPr id="4" name="Text 1"/>
+          <p:cNvSpPr/>
+          <p:nvPr/>
+        </p:nvSpPr>
+        <p:spPr>
+          <a:xfrm>
+            <a:off x="594360" y="347472"/>
+            <a:ext cx="10058400" cy="274320"/>
+          </a:xfrm>
+          <a:prstGeom prst="rect">
+            <a:avLst/>
+          </a:prstGeom>
+          <a:noFill/>
+          <a:ln/>
+        </p:spPr>
+        <p:txBody>
+          <a:bodyPr wrap="square" lIns="0" tIns="0" rIns="0" bIns="0" rtlCol="0" anchor="t"/>
+          <a:lstStyle/>
+          <a:p>
+            <a:pPr indent="0" marL="0">
+              <a:buNone/>
+            </a:pPr>
+            <a:r>
+              <a:rPr lang="en-US" sz="1200" b="1" dirty="0">
+                <a:solidFill>
+                  <a:srgbClr val="235AF5"/>
+                </a:solidFill>
+                <a:latin typeface="Aptos" pitchFamily="34" charset="0"/>
+                <a:ea typeface="Aptos" pitchFamily="34" charset="-122"/>
+                <a:cs typeface="Aptos" pitchFamily="34" charset="-120"/>
+              </a:rPr>
+              <a:t>FICTIONAL PRACTICE</a:t>
+            </a:r>
+            <a:endParaRPr lang="en-US" sz="1200" dirty="0"/>
+          </a:p>
+        </p:txBody>
+      </p:sp>
+      <p:sp>
+        <p:nvSpPr>
+          <p:cNvPr id="5" name="Text 2"/>
+          <p:cNvSpPr/>
+          <p:nvPr/>
+        </p:nvSpPr>
+        <p:spPr>
+          <a:xfrm>
+            <a:off x="594360" y="850392"/>
+            <a:ext cx="11018520" cy="731520"/>
+          </a:xfrm>
+          <a:prstGeom prst="rect">
+            <a:avLst/>
+          </a:prstGeom>
+          <a:noFill/>
+          <a:ln/>
+        </p:spPr>
+        <p:txBody>
+          <a:bodyPr wrap="square" lIns="0" tIns="0" rIns="0" bIns="0" rtlCol="0" anchor="t"/>
+          <a:lstStyle/>
+          <a:p>
+            <a:pPr indent="0" marL="0">
+              <a:buNone/>
+            </a:pPr>
+            <a:r>
+              <a:rPr lang="en-US" sz="3000" b="1" dirty="0">
+                <a:solidFill>
+                  <a:srgbClr val="0D1933"/>
+                </a:solidFill>
+                <a:latin typeface="Aptos" pitchFamily="34" charset="0"/>
+                <a:ea typeface="Aptos" pitchFamily="34" charset="-122"/>
+                <a:cs typeface="Aptos" pitchFamily="34" charset="-120"/>
+              </a:rPr>
+              <a:t>Rehearse the complete review sequence</a:t>
+            </a:r>
+            <a:endParaRPr lang="en-US" sz="3000" dirty="0"/>
+          </a:p>
+        </p:txBody>
+      </p:sp>
+      <p:sp>
+        <p:nvSpPr>
+          <p:cNvPr id="6" name="Shape 3"/>
+          <p:cNvSpPr/>
+          <p:nvPr/>
+        </p:nvSpPr>
+        <p:spPr>
+          <a:xfrm>
+            <a:off x="594360" y="1856232"/>
+            <a:ext cx="3520440" cy="3557016"/>
+          </a:xfrm>
+          <a:prstGeom prst="rect">
+            <a:avLst/>
+          </a:prstGeom>
+          <a:solidFill>
+            <a:srgbClr val="FFFFFF"/>
+          </a:solidFill>
+          <a:ln w="12700">
+            <a:solidFill>
+              <a:srgbClr val="FFFFFF">
+                <a:alpha val="0"/>
+              </a:srgbClr>
+            </a:solidFill>
+            <a:prstDash val="solid"/>
+          </a:ln>
+        </p:spPr>
+      </p:sp>
+      <p:sp>
+        <p:nvSpPr>
+          <p:cNvPr id="7" name="Shape 4"/>
+          <p:cNvSpPr/>
+          <p:nvPr/>
+        </p:nvSpPr>
+        <p:spPr>
+          <a:xfrm>
+            <a:off x="594360" y="1856232"/>
+            <a:ext cx="54864" cy="3557016"/>
+          </a:xfrm>
+          <a:prstGeom prst="rect">
+            <a:avLst/>
+          </a:prstGeom>
+          <a:solidFill>
+            <a:srgbClr val="235AF5"/>
+          </a:solidFill>
+          <a:ln w="12700">
+            <a:solidFill>
+              <a:srgbClr val="235AF5">
+                <a:alpha val="0"/>
+              </a:srgbClr>
+            </a:solidFill>
+            <a:prstDash val="solid"/>
+          </a:ln>
+        </p:spPr>
+      </p:sp>
+      <p:sp>
+        <p:nvSpPr>
+          <p:cNvPr id="8" name="Text 5"/>
+          <p:cNvSpPr/>
+          <p:nvPr/>
+        </p:nvSpPr>
+        <p:spPr>
+          <a:xfrm>
+            <a:off x="804672" y="2057400"/>
+            <a:ext cx="3017520" cy="365760"/>
+          </a:xfrm>
+          <a:prstGeom prst="rect">
+            <a:avLst/>
+          </a:prstGeom>
+          <a:noFill/>
+          <a:ln/>
+        </p:spPr>
+        <p:txBody>
+          <a:bodyPr wrap="square" lIns="0" tIns="0" rIns="0" bIns="0" rtlCol="0" anchor="t"/>
+          <a:lstStyle/>
+          <a:p>
+            <a:pPr indent="0" marL="0">
+              <a:buNone/>
+            </a:pPr>
+            <a:r>
+              <a:rPr lang="en-US" sz="1300" b="1" dirty="0">
+                <a:solidFill>
+                  <a:srgbClr val="235AF5"/>
+                </a:solidFill>
+                <a:latin typeface="Aptos" pitchFamily="34" charset="0"/>
+                <a:ea typeface="Aptos" pitchFamily="34" charset="-122"/>
+                <a:cs typeface="Aptos" pitchFamily="34" charset="-120"/>
+              </a:rPr>
+              <a:t>01</a:t>
+            </a:r>
+            <a:endParaRPr lang="en-US" sz="1300" dirty="0"/>
+          </a:p>
+        </p:txBody>
+      </p:sp>
+      <p:sp>
+        <p:nvSpPr>
+          <p:cNvPr id="9" name="Text 6"/>
+          <p:cNvSpPr/>
+          <p:nvPr/>
+        </p:nvSpPr>
+        <p:spPr>
+          <a:xfrm>
+            <a:off x="804672" y="2587752"/>
+            <a:ext cx="3072384" cy="731520"/>
+          </a:xfrm>
+          <a:prstGeom prst="rect">
+            <a:avLst/>
+          </a:prstGeom>
+          <a:noFill/>
+          <a:ln/>
+        </p:spPr>
+        <p:txBody>
+          <a:bodyPr wrap="square" lIns="0" tIns="0" rIns="0" bIns="0" rtlCol="0" anchor="t"/>
+          <a:lstStyle/>
+          <a:p>
+            <a:pPr indent="0" marL="0">
+              <a:buNone/>
+            </a:pPr>
+            <a:r>
+              <a:rPr lang="en-US" sz="2200" b="1" dirty="0">
+                <a:solidFill>
+                  <a:srgbClr val="0D1933"/>
+                </a:solidFill>
+                <a:latin typeface="Aptos" pitchFamily="34" charset="0"/>
+                <a:ea typeface="Aptos" pitchFamily="34" charset="-122"/>
+                <a:cs typeface="Aptos" pitchFamily="34" charset="-120"/>
+              </a:rPr>
+              <a:t>Open the municipal retrofit</a:t>
+            </a:r>
+            <a:endParaRPr lang="en-US" sz="2200" dirty="0"/>
+          </a:p>
+        </p:txBody>
+      </p:sp>
+      <p:sp>
+        <p:nvSpPr>
+          <p:cNvPr id="10" name="Text 7"/>
+          <p:cNvSpPr/>
+          <p:nvPr/>
+        </p:nvSpPr>
+        <p:spPr>
+          <a:xfrm>
+            <a:off x="804672" y="3465576"/>
+            <a:ext cx="3035808" cy="1673352"/>
+          </a:xfrm>
+          <a:prstGeom prst="rect">
+            <a:avLst/>
+          </a:prstGeom>
+          <a:noFill/>
+          <a:ln/>
+        </p:spPr>
+        <p:txBody>
+          <a:bodyPr wrap="square" lIns="0" tIns="0" rIns="0" bIns="0" rtlCol="0" anchor="t"/>
+          <a:lstStyle/>
+          <a:p>
+            <a:pPr indent="0" marL="0">
+              <a:buNone/>
+            </a:pPr>
+            <a:r>
+              <a:rPr lang="en-US" sz="1800" dirty="0">
+                <a:solidFill>
+                  <a:srgbClr val="172641"/>
+                </a:solidFill>
+                <a:latin typeface="Aptos" pitchFamily="34" charset="0"/>
+                <a:ea typeface="Aptos" pitchFamily="34" charset="-122"/>
+                <a:cs typeface="Aptos" pitchFamily="34" charset="-120"/>
+              </a:rPr>
+              <a:t>In the demo, choose Practice the municipal retrofit bid. Renew the sample insurance and review ten requirements.</a:t>
+            </a:r>
+            <a:endParaRPr lang="en-US" sz="1800" dirty="0"/>
+          </a:p>
+        </p:txBody>
+      </p:sp>
+      <p:sp>
+        <p:nvSpPr>
+          <p:cNvPr id="11" name="Shape 8"/>
+          <p:cNvSpPr/>
+          <p:nvPr/>
+        </p:nvSpPr>
+        <p:spPr>
+          <a:xfrm>
+            <a:off x="4343400" y="1856232"/>
+            <a:ext cx="3520440" cy="3557016"/>
+          </a:xfrm>
+          <a:prstGeom prst="rect">
+            <a:avLst/>
+          </a:prstGeom>
+          <a:solidFill>
+            <a:srgbClr val="FFFFFF"/>
+          </a:solidFill>
+          <a:ln w="12700">
+            <a:solidFill>
+              <a:srgbClr val="FFFFFF">
+                <a:alpha val="0"/>
+              </a:srgbClr>
+            </a:solidFill>
+            <a:prstDash val="solid"/>
+          </a:ln>
+        </p:spPr>
+      </p:sp>
+      <p:sp>
+        <p:nvSpPr>
+          <p:cNvPr id="12" name="Shape 9"/>
+          <p:cNvSpPr/>
+          <p:nvPr/>
+        </p:nvSpPr>
+        <p:spPr>
+          <a:xfrm>
+            <a:off x="4343400" y="1856232"/>
+            <a:ext cx="54864" cy="3557016"/>
+          </a:xfrm>
+          <a:prstGeom prst="rect">
+            <a:avLst/>
+          </a:prstGeom>
+          <a:solidFill>
+            <a:srgbClr val="F2B337"/>
+          </a:solidFill>
+          <a:ln w="12700">
+            <a:solidFill>
+              <a:srgbClr val="F2B337">
+                <a:alpha val="0"/>
+              </a:srgbClr>
+            </a:solidFill>
+            <a:prstDash val="solid"/>
+          </a:ln>
+        </p:spPr>
+      </p:sp>
+      <p:sp>
+        <p:nvSpPr>
+          <p:cNvPr id="13" name="Text 10"/>
+          <p:cNvSpPr/>
+          <p:nvPr/>
+        </p:nvSpPr>
+        <p:spPr>
+          <a:xfrm>
+            <a:off x="4553712" y="2057400"/>
+            <a:ext cx="3017520" cy="365760"/>
+          </a:xfrm>
+          <a:prstGeom prst="rect">
+            <a:avLst/>
+          </a:prstGeom>
+          <a:noFill/>
+          <a:ln/>
+        </p:spPr>
+        <p:txBody>
+          <a:bodyPr wrap="square" lIns="0" tIns="0" rIns="0" bIns="0" rtlCol="0" anchor="t"/>
+          <a:lstStyle/>
+          <a:p>
+            <a:pPr indent="0" marL="0">
+              <a:buNone/>
+            </a:pPr>
+            <a:r>
+              <a:rPr lang="en-US" sz="1300" b="1" dirty="0">
+                <a:solidFill>
+                  <a:srgbClr val="235AF5"/>
+                </a:solidFill>
+                <a:latin typeface="Aptos" pitchFamily="34" charset="0"/>
+                <a:ea typeface="Aptos" pitchFamily="34" charset="-122"/>
+                <a:cs typeface="Aptos" pitchFamily="34" charset="-120"/>
+              </a:rPr>
+              <a:t>02</a:t>
+            </a:r>
+            <a:endParaRPr lang="en-US" sz="1300" dirty="0"/>
+          </a:p>
+        </p:txBody>
+      </p:sp>
+      <p:sp>
+        <p:nvSpPr>
+          <p:cNvPr id="14" name="Text 11"/>
+          <p:cNvSpPr/>
+          <p:nvPr/>
+        </p:nvSpPr>
+        <p:spPr>
+          <a:xfrm>
+            <a:off x="4553712" y="2587752"/>
+            <a:ext cx="3072384" cy="731520"/>
+          </a:xfrm>
+          <a:prstGeom prst="rect">
+            <a:avLst/>
+          </a:prstGeom>
+          <a:noFill/>
+          <a:ln/>
+        </p:spPr>
+        <p:txBody>
+          <a:bodyPr wrap="square" lIns="0" tIns="0" rIns="0" bIns="0" rtlCol="0" anchor="t"/>
+          <a:lstStyle/>
+          <a:p>
+            <a:pPr indent="0" marL="0">
+              <a:buNone/>
+            </a:pPr>
+            <a:r>
+              <a:rPr lang="en-US" sz="2200" b="1" dirty="0">
+                <a:solidFill>
+                  <a:srgbClr val="0D1933"/>
+                </a:solidFill>
+                <a:latin typeface="Aptos" pitchFamily="34" charset="0"/>
+                <a:ea typeface="Aptos" pitchFamily="34" charset="-122"/>
+                <a:cs typeface="Aptos" pitchFamily="34" charset="-120"/>
+              </a:rPr>
+              <a:t>Record the review trail</a:t>
+            </a:r>
+            <a:endParaRPr lang="en-US" sz="2200" dirty="0"/>
+          </a:p>
+        </p:txBody>
+      </p:sp>
+      <p:sp>
+        <p:nvSpPr>
+          <p:cNvPr id="15" name="Text 12"/>
+          <p:cNvSpPr/>
+          <p:nvPr/>
+        </p:nvSpPr>
+        <p:spPr>
+          <a:xfrm>
+            <a:off x="4553712" y="3465576"/>
+            <a:ext cx="3035808" cy="1673352"/>
+          </a:xfrm>
+          <a:prstGeom prst="rect">
+            <a:avLst/>
+          </a:prstGeom>
+          <a:noFill/>
+          <a:ln/>
+        </p:spPr>
+        <p:txBody>
+          <a:bodyPr wrap="square" lIns="0" tIns="0" rIns="0" bIns="0" rtlCol="0" anchor="t"/>
+          <a:lstStyle/>
+          <a:p>
+            <a:pPr indent="0" marL="0">
+              <a:buNone/>
+            </a:pPr>
+            <a:r>
+              <a:rPr lang="en-US" sz="1800" dirty="0">
+                <a:solidFill>
+                  <a:srgbClr val="172641"/>
+                </a:solidFill>
+                <a:latin typeface="Aptos" pitchFamily="34" charset="0"/>
+                <a:ea typeface="Aptos" pitchFamily="34" charset="-122"/>
+                <a:cs typeface="Aptos" pitchFamily="34" charset="-120"/>
+              </a:rPr>
+              <a:t>Add review notes, sign off, record a reasoned decision and finish the three assigned training tasks.</a:t>
+            </a:r>
+            <a:endParaRPr lang="en-US" sz="1800" dirty="0"/>
+          </a:p>
+        </p:txBody>
+      </p:sp>
+      <p:sp>
+        <p:nvSpPr>
+          <p:cNvPr id="16" name="Shape 13"/>
+          <p:cNvSpPr/>
+          <p:nvPr/>
+        </p:nvSpPr>
+        <p:spPr>
+          <a:xfrm>
+            <a:off x="8092440" y="1856232"/>
+            <a:ext cx="3520440" cy="3557016"/>
+          </a:xfrm>
+          <a:prstGeom prst="rect">
+            <a:avLst/>
+          </a:prstGeom>
+          <a:solidFill>
+            <a:srgbClr val="FFFFFF"/>
+          </a:solidFill>
+          <a:ln w="12700">
+            <a:solidFill>
+              <a:srgbClr val="FFFFFF">
+                <a:alpha val="0"/>
+              </a:srgbClr>
+            </a:solidFill>
+            <a:prstDash val="solid"/>
+          </a:ln>
+        </p:spPr>
+      </p:sp>
+      <p:sp>
+        <p:nvSpPr>
+          <p:cNvPr id="17" name="Shape 14"/>
+          <p:cNvSpPr/>
+          <p:nvPr/>
+        </p:nvSpPr>
+        <p:spPr>
+          <a:xfrm>
+            <a:off x="8092440" y="1856232"/>
+            <a:ext cx="54864" cy="3557016"/>
+          </a:xfrm>
+          <a:prstGeom prst="rect">
+            <a:avLst/>
+          </a:prstGeom>
+          <a:solidFill>
+            <a:srgbClr val="235AF5"/>
+          </a:solidFill>
+          <a:ln w="12700">
+            <a:solidFill>
+              <a:srgbClr val="235AF5">
+                <a:alpha val="0"/>
+              </a:srgbClr>
+            </a:solidFill>
+            <a:prstDash val="solid"/>
+          </a:ln>
+        </p:spPr>
+      </p:sp>
+      <p:sp>
+        <p:nvSpPr>
+          <p:cNvPr id="18" name="Text 15"/>
+          <p:cNvSpPr/>
+          <p:nvPr/>
+        </p:nvSpPr>
+        <p:spPr>
+          <a:xfrm>
+            <a:off x="8302752" y="2057400"/>
+            <a:ext cx="3017520" cy="365760"/>
+          </a:xfrm>
+          <a:prstGeom prst="rect">
+            <a:avLst/>
+          </a:prstGeom>
+          <a:noFill/>
+          <a:ln/>
+        </p:spPr>
+        <p:txBody>
+          <a:bodyPr wrap="square" lIns="0" tIns="0" rIns="0" bIns="0" rtlCol="0" anchor="t"/>
+          <a:lstStyle/>
+          <a:p>
+            <a:pPr indent="0" marL="0">
+              <a:buNone/>
+            </a:pPr>
+            <a:r>
+              <a:rPr lang="en-US" sz="1300" b="1" dirty="0">
+                <a:solidFill>
+                  <a:srgbClr val="235AF5"/>
+                </a:solidFill>
+                <a:latin typeface="Aptos" pitchFamily="34" charset="0"/>
+                <a:ea typeface="Aptos" pitchFamily="34" charset="-122"/>
+                <a:cs typeface="Aptos" pitchFamily="34" charset="-120"/>
+              </a:rPr>
+              <a:t>03</a:t>
+            </a:r>
+            <a:endParaRPr lang="en-US" sz="1300" dirty="0"/>
+          </a:p>
+        </p:txBody>
+      </p:sp>
+      <p:sp>
+        <p:nvSpPr>
+          <p:cNvPr id="19" name="Text 16"/>
+          <p:cNvSpPr/>
+          <p:nvPr/>
+        </p:nvSpPr>
+        <p:spPr>
+          <a:xfrm>
+            <a:off x="8302752" y="2587752"/>
+            <a:ext cx="3072384" cy="731520"/>
+          </a:xfrm>
+          <a:prstGeom prst="rect">
+            <a:avLst/>
+          </a:prstGeom>
+          <a:noFill/>
+          <a:ln/>
+        </p:spPr>
+        <p:txBody>
+          <a:bodyPr wrap="square" lIns="0" tIns="0" rIns="0" bIns="0" rtlCol="0" anchor="t"/>
+          <a:lstStyle/>
+          <a:p>
+            <a:pPr indent="0" marL="0">
+              <a:buNone/>
+            </a:pPr>
+            <a:r>
+              <a:rPr lang="en-US" sz="2200" b="1" dirty="0">
+                <a:solidFill>
+                  <a:srgbClr val="0D1933"/>
+                </a:solidFill>
+                <a:latin typeface="Aptos" pitchFamily="34" charset="0"/>
+                <a:ea typeface="Aptos" pitchFamily="34" charset="-122"/>
+                <a:cs typeface="Aptos" pitchFamily="34" charset="-120"/>
+              </a:rPr>
+              <a:t>Test what changes</a:t>
+            </a:r>
+            <a:endParaRPr lang="en-US" sz="2200" dirty="0"/>
+          </a:p>
+        </p:txBody>
+      </p:sp>
+      <p:sp>
+        <p:nvSpPr>
+          <p:cNvPr id="20" name="Text 17"/>
+          <p:cNvSpPr/>
+          <p:nvPr/>
+        </p:nvSpPr>
+        <p:spPr>
+          <a:xfrm>
+            <a:off x="8302752" y="3465576"/>
+            <a:ext cx="3035808" cy="1673352"/>
+          </a:xfrm>
+          <a:prstGeom prst="rect">
+            <a:avLst/>
+          </a:prstGeom>
+          <a:noFill/>
+          <a:ln/>
+        </p:spPr>
+        <p:txBody>
+          <a:bodyPr wrap="square" lIns="0" tIns="0" rIns="0" bIns="0" rtlCol="0" anchor="t"/>
+          <a:lstStyle/>
+          <a:p>
+            <a:pPr indent="0" marL="0">
+              <a:buNone/>
+            </a:pPr>
+            <a:r>
+              <a:rPr lang="en-US" sz="1800" dirty="0">
+                <a:solidFill>
+                  <a:srgbClr val="172641"/>
+                </a:solidFill>
+                <a:latin typeface="Aptos" pitchFamily="34" charset="0"/>
+                <a:ea typeface="Aptos" pitchFamily="34" charset="-122"/>
+                <a:cs typeface="Aptos" pitchFamily="34" charset="-120"/>
+              </a:rPr>
+              <a:t>Create an outline, replace placeholders with fictional text, approve and record a fictional receipt. Then simulate an amendment.</a:t>
+            </a:r>
+            <a:endParaRPr lang="en-US" sz="1800" dirty="0"/>
+          </a:p>
+        </p:txBody>
+      </p:sp>
+      <p:sp>
+        <p:nvSpPr>
+          <p:cNvPr id="21" name="Shape 18"/>
+          <p:cNvSpPr/>
+          <p:nvPr/>
+        </p:nvSpPr>
+        <p:spPr>
+          <a:xfrm>
+            <a:off x="594360" y="5650992"/>
+            <a:ext cx="11018520" cy="576072"/>
+          </a:xfrm>
+          <a:prstGeom prst="rect">
+            <a:avLst/>
+          </a:prstGeom>
+          <a:solidFill>
+            <a:srgbClr val="0D1933"/>
+          </a:solidFill>
+          <a:ln w="12700">
+            <a:solidFill>
+              <a:srgbClr val="0D1933">
+                <a:alpha val="0"/>
+              </a:srgbClr>
+            </a:solidFill>
+            <a:prstDash val="solid"/>
+          </a:ln>
+        </p:spPr>
+      </p:sp>
+      <p:sp>
+        <p:nvSpPr>
+          <p:cNvPr id="22" name="Text 19"/>
+          <p:cNvSpPr/>
+          <p:nvPr/>
+        </p:nvSpPr>
+        <p:spPr>
+          <a:xfrm>
+            <a:off x="777240" y="5779008"/>
+            <a:ext cx="10607040" cy="374904"/>
+          </a:xfrm>
+          <a:prstGeom prst="rect">
+            <a:avLst/>
+          </a:prstGeom>
+          <a:noFill/>
+          <a:ln/>
+        </p:spPr>
+        <p:txBody>
+          <a:bodyPr wrap="square" lIns="0" tIns="0" rIns="0" bIns="0" rtlCol="0" anchor="t"/>
+          <a:lstStyle/>
+          <a:p>
+            <a:pPr indent="0" marL="0">
+              <a:buNone/>
+            </a:pPr>
+            <a:r>
+              <a:rPr lang="en-US" sz="1400" dirty="0">
+                <a:solidFill>
+                  <a:srgbClr val="FFFFFF"/>
+                </a:solidFill>
+                <a:latin typeface="Aptos" pitchFamily="34" charset="0"/>
+                <a:ea typeface="Aptos" pitchFamily="34" charset="-122"/>
+                <a:cs typeface="Aptos" pitchFamily="34" charset="-120"/>
+              </a:rPr>
+              <a:t>Fictional local exercise only. Nothing is submitted or saved to a company.</a:t>
+            </a:r>
+            <a:endParaRPr lang="en-US" sz="1400" dirty="0"/>
+          </a:p>
+        </p:txBody>
+      </p:sp>
+      <p:sp>
+        <p:nvSpPr>
+          <p:cNvPr id="23" name="Text 20"/>
+          <p:cNvSpPr/>
+          <p:nvPr/>
+        </p:nvSpPr>
+        <p:spPr>
+          <a:xfrm>
+            <a:off x="594360" y="6510528"/>
+            <a:ext cx="9144000" cy="182880"/>
+          </a:xfrm>
+          <a:prstGeom prst="rect">
+            <a:avLst/>
+          </a:prstGeom>
+          <a:noFill/>
+          <a:ln/>
+        </p:spPr>
+        <p:txBody>
+          <a:bodyPr wrap="square" lIns="0" tIns="0" rIns="0" bIns="0" rtlCol="0" anchor="t"/>
+          <a:lstStyle/>
+          <a:p>
+            <a:pPr indent="0" marL="0">
+              <a:buNone/>
+            </a:pPr>
+            <a:r>
+              <a:rPr lang="en-US" sz="900" dirty="0">
+                <a:solidFill>
+                  <a:srgbClr val="506178"/>
+                </a:solidFill>
+                <a:latin typeface="Aptos" pitchFamily="34" charset="0"/>
+                <a:ea typeface="Aptos" pitchFamily="34" charset="-122"/>
+                <a:cs typeface="Aptos" pitchFamily="34" charset="-120"/>
+              </a:rPr>
+              <a:t>BidXchange  /  HOW TO USE THE APP</a:t>
+            </a:r>
+            <a:endParaRPr lang="en-US" sz="900" dirty="0"/>
+          </a:p>
+        </p:txBody>
+      </p:sp>
+      <p:sp>
+        <p:nvSpPr>
+          <p:cNvPr id="24" name="Text 21"/>
+          <p:cNvSpPr/>
+          <p:nvPr/>
+        </p:nvSpPr>
+        <p:spPr>
+          <a:xfrm>
+            <a:off x="11000232" y="6473952"/>
+            <a:ext cx="594360" cy="246888"/>
+          </a:xfrm>
+          <a:prstGeom prst="rect">
+            <a:avLst/>
+          </a:prstGeom>
+          <a:noFill/>
+          <a:ln/>
+        </p:spPr>
+        <p:txBody>
+          <a:bodyPr wrap="square" lIns="0" tIns="0" rIns="0" bIns="0" rtlCol="0" anchor="t"/>
+          <a:lstStyle/>
+          <a:p>
+            <a:pPr algn="r" indent="0" marL="0">
+              <a:buNone/>
+            </a:pPr>
+            <a:r>
+              <a:rPr lang="en-US" sz="1100" dirty="0">
+                <a:solidFill>
+                  <a:srgbClr val="506178"/>
+                </a:solidFill>
+                <a:latin typeface="Aptos" pitchFamily="34" charset="0"/>
+                <a:ea typeface="Aptos" pitchFamily="34" charset="-122"/>
+                <a:cs typeface="Aptos" pitchFamily="34" charset="-120"/>
+              </a:rPr>
+              <a:t>26</a:t>
+            </a:r>
+            <a:endParaRPr lang="en-US" sz="1100" dirty="0"/>
+          </a:p>
+        </p:txBody>
+      </p:sp>
+    </p:spTree>
+  </p:cSld>
+  <p:clrMapOvr>
+    <a:masterClrMapping/>
+  </p:clrMapOvr>
+</p:sld>
+</file>
+
 <file path=ppt/slides/slide3.xml><?xml version="1.0" encoding="utf-8"?>
 <p:sld xmlns:a="http://schemas.openxmlformats.org/drawingml/2006/main" xmlns:r="http://schemas.openxmlformats.org/officeDocument/2006/relationships" xmlns:p="http://schemas.openxmlformats.org/presentationml/2006/main">
   <p:cSld name="Slide 3">
@@ -19470,7 +21236,7 @@
                 <a:ea typeface="Aptos" pitchFamily="34" charset="-122"/>
                 <a:cs typeface="Aptos" pitchFamily="34" charset="-120"/>
               </a:rPr>
-              <a:t>Opening a pursuit can reopen linked requirements and create a follow-up task. Reaffirm stale decisions.</a:t>
+              <a:t>Scheduled checks and pursuit access can reopen linked requirements. Review reminders and reaffirm stale decisions.</a:t>
             </a:r>
             <a:endParaRPr lang="en-US" sz="1800" dirty="0"/>
           </a:p>

</xml_diff>

<commit_message>
Add audited requirement archive merge and restore workflows
</commit_message>
<xml_diff>
--- a/docs/presentations/BidXchange-How-To-Use.pptx
+++ b/docs/presentations/BidXchange-How-To-Use.pptx
@@ -31,9 +31,10 @@
     <p:sldId id="279" r:id="rId25"/>
     <p:sldId id="280" r:id="rId26"/>
     <p:sldId id="281" r:id="rId27"/>
+    <p:sldId id="282" r:id="rId28"/>
   </p:sldIdLst>
   <p:notesMasterIdLst>
-    <p:notesMasterId r:id="rId28"/>
+    <p:notesMasterId r:id="rId29"/>
   </p:notesMasterIdLst>
   <p:sldSz cx="12192000" cy="6858000"/>
   <p:notesSz cx="6858000" cy="12192000"/>
@@ -2135,6 +2136,94 @@
             <a:fld id="{F7021451-1387-4CA6-816F-3879F97B5CBC}" type="slidenum">
               <a:rPr lang="en-US"/>
               <a:t>26</a:t>
+            </a:fld>
+            <a:endParaRPr lang="en-US"/>
+          </a:p>
+        </p:txBody>
+      </p:sp>
+    </p:spTree>
+    <p:extLst>
+      <p:ext uri="{BB962C8B-B14F-4D97-AF65-F5344CB8AC3E}">
+        <p14:creationId xmlns:p14="http://schemas.microsoft.com/office/powerpoint/2010/main" val="1024086991"/>
+      </p:ext>
+    </p:extLst>
+  </p:cSld>
+  <p:clrMapOvr>
+    <a:masterClrMapping/>
+  </p:clrMapOvr>
+</p:notes>
+</file>
+
+<file path=ppt/notesSlides/notesSlide27.xml><?xml version="1.0" encoding="utf-8"?>
+<p:notes xmlns:a="http://schemas.openxmlformats.org/drawingml/2006/main" xmlns:r="http://schemas.openxmlformats.org/officeDocument/2006/relationships" xmlns:p="http://schemas.openxmlformats.org/presentationml/2006/main">
+  <p:cSld>
+    <p:spTree>
+      <p:nvGrpSpPr>
+        <p:cNvPr id="1" name=""/>
+        <p:cNvGrpSpPr/>
+        <p:nvPr/>
+      </p:nvGrpSpPr>
+      <p:grpSpPr>
+        <a:xfrm>
+          <a:off x="0" y="0"/>
+          <a:ext cx="0" cy="0"/>
+          <a:chOff x="0" y="0"/>
+          <a:chExt cx="0" cy="0"/>
+        </a:xfrm>
+      </p:grpSpPr>
+      <p:sp>
+        <p:nvSpPr>
+          <p:cNvPr id="2" name="Slide Image Placeholder 1"/>
+          <p:cNvSpPr>
+            <a:spLocks noGrp="1" noRot="1" noChangeAspect="1"/>
+          </p:cNvSpPr>
+          <p:nvPr>
+            <p:ph type="sldImg"/>
+          </p:nvPr>
+        </p:nvSpPr>
+        <p:spPr/>
+      </p:sp>
+      <p:sp>
+        <p:nvSpPr>
+          <p:cNvPr id="3" name="Notes Placeholder 2"/>
+          <p:cNvSpPr>
+            <a:spLocks noGrp="1"/>
+          </p:cNvSpPr>
+          <p:nvPr>
+            <p:ph type="body" idx="1"/>
+          </p:nvPr>
+        </p:nvSpPr>
+        <p:spPr/>
+        <p:txBody>
+          <a:bodyPr/>
+          <a:lstStyle/>
+          <a:p>
+            <a:r>
+              <a:rPr lang="en-US" dirty="0"/>
+              <a:t>Administrators and capture managers can correct requirements. Evidence approvals and tasks remain on their original rows; merge does not transfer approval to the target. Review and link appropriate evidence to the combined requirement. Existing decisions and frozen draft snapshots stay in history, but their context becomes stale. Restore does not undo a later target edit. Archived rows are excluded from active sign-off, new outlines and active AI/research requirements. Saved response answers need reconciliation before another release. Do not archive an obligation just to remove a blocker: review the official source and document the reason.</a:t>
+            </a:r>
+            <a:endParaRPr lang="en-US" dirty="0"/>
+          </a:p>
+        </p:txBody>
+      </p:sp>
+      <p:sp>
+        <p:nvSpPr>
+          <p:cNvPr id="4" name="Slide Number Placeholder 3"/>
+          <p:cNvSpPr>
+            <a:spLocks noGrp="1"/>
+          </p:cNvSpPr>
+          <p:nvPr>
+            <p:ph type="sldNum" sz="quarter" idx="10"/>
+          </p:nvPr>
+        </p:nvSpPr>
+        <p:spPr/>
+        <p:txBody>
+          <a:bodyPr/>
+          <a:lstStyle/>
+          <a:p>
+            <a:fld id="{F7021451-1387-4CA6-816F-3879F97B5CBC}" type="slidenum">
+              <a:rPr lang="en-US"/>
+              <a:t>27</a:t>
             </a:fld>
             <a:endParaRPr lang="en-US"/>
           </a:p>
@@ -17672,6 +17761,800 @@
 </p:sld>
 </file>
 
+<file path=ppt/slides/slide27.xml><?xml version="1.0" encoding="utf-8"?>
+<p:sld xmlns:a="http://schemas.openxmlformats.org/drawingml/2006/main" xmlns:r="http://schemas.openxmlformats.org/officeDocument/2006/relationships" xmlns:p="http://schemas.openxmlformats.org/presentationml/2006/main">
+  <p:cSld name="Slide 27">
+    <p:bg>
+      <p:bgPr>
+        <a:solidFill>
+          <a:srgbClr val="F3F6FB"/>
+        </a:solidFill>
+      </p:bgPr>
+    </p:bg>
+    <p:spTree>
+      <p:nvGrpSpPr>
+        <p:cNvPr id="1" name=""/>
+        <p:cNvGrpSpPr/>
+        <p:nvPr/>
+      </p:nvGrpSpPr>
+      <p:grpSpPr>
+        <a:xfrm>
+          <a:off x="0" y="0"/>
+          <a:ext cx="0" cy="0"/>
+          <a:chOff x="0" y="0"/>
+          <a:chExt cx="0" cy="0"/>
+        </a:xfrm>
+      </p:grpSpPr>
+      <p:sp>
+        <p:nvSpPr>
+          <p:cNvPr id="3" name="Shape 0"/>
+          <p:cNvSpPr/>
+          <p:nvPr/>
+        </p:nvSpPr>
+        <p:spPr>
+          <a:xfrm>
+            <a:off x="0" y="0"/>
+            <a:ext cx="12191695" cy="82296"/>
+          </a:xfrm>
+          <a:prstGeom prst="rect">
+            <a:avLst/>
+          </a:prstGeom>
+          <a:solidFill>
+            <a:srgbClr val="235AF5"/>
+          </a:solidFill>
+          <a:ln w="12700">
+            <a:solidFill>
+              <a:srgbClr val="235AF5">
+                <a:alpha val="0"/>
+              </a:srgbClr>
+            </a:solidFill>
+            <a:prstDash val="solid"/>
+          </a:ln>
+        </p:spPr>
+      </p:sp>
+      <p:sp>
+        <p:nvSpPr>
+          <p:cNvPr id="4" name="Text 1"/>
+          <p:cNvSpPr/>
+          <p:nvPr/>
+        </p:nvSpPr>
+        <p:spPr>
+          <a:xfrm>
+            <a:off x="594360" y="347472"/>
+            <a:ext cx="10058400" cy="274320"/>
+          </a:xfrm>
+          <a:prstGeom prst="rect">
+            <a:avLst/>
+          </a:prstGeom>
+          <a:noFill/>
+          <a:ln/>
+        </p:spPr>
+        <p:txBody>
+          <a:bodyPr wrap="square" lIns="0" tIns="0" rIns="0" bIns="0" rtlCol="0" anchor="t"/>
+          <a:lstStyle/>
+          <a:p>
+            <a:pPr indent="0" marL="0">
+              <a:buNone/>
+            </a:pPr>
+            <a:r>
+              <a:rPr lang="en-US" sz="1200" b="1" dirty="0">
+                <a:solidFill>
+                  <a:srgbClr val="235AF5"/>
+                </a:solidFill>
+                <a:latin typeface="Aptos" pitchFamily="34" charset="0"/>
+                <a:ea typeface="Aptos" pitchFamily="34" charset="-122"/>
+                <a:cs typeface="Aptos" pitchFamily="34" charset="-120"/>
+              </a:rPr>
+              <a:t>REQUIREMENT CORRECTIONS</a:t>
+            </a:r>
+            <a:endParaRPr lang="en-US" sz="1200" dirty="0"/>
+          </a:p>
+        </p:txBody>
+      </p:sp>
+      <p:sp>
+        <p:nvSpPr>
+          <p:cNvPr id="5" name="Text 2"/>
+          <p:cNvSpPr/>
+          <p:nvPr/>
+        </p:nvSpPr>
+        <p:spPr>
+          <a:xfrm>
+            <a:off x="594360" y="850392"/>
+            <a:ext cx="11018520" cy="731520"/>
+          </a:xfrm>
+          <a:prstGeom prst="rect">
+            <a:avLst/>
+          </a:prstGeom>
+          <a:noFill/>
+          <a:ln/>
+        </p:spPr>
+        <p:txBody>
+          <a:bodyPr wrap="square" lIns="0" tIns="0" rIns="0" bIns="0" rtlCol="0" anchor="t"/>
+          <a:lstStyle/>
+          <a:p>
+            <a:pPr indent="0" marL="0">
+              <a:buNone/>
+            </a:pPr>
+            <a:r>
+              <a:rPr lang="en-US" sz="3000" b="1" dirty="0">
+                <a:solidFill>
+                  <a:srgbClr val="0D1933"/>
+                </a:solidFill>
+                <a:latin typeface="Aptos" pitchFamily="34" charset="0"/>
+                <a:ea typeface="Aptos" pitchFamily="34" charset="-122"/>
+                <a:cs typeface="Aptos" pitchFamily="34" charset="-120"/>
+              </a:rPr>
+              <a:t>Correct the register without losing history</a:t>
+            </a:r>
+            <a:endParaRPr lang="en-US" sz="3000" dirty="0"/>
+          </a:p>
+        </p:txBody>
+      </p:sp>
+      <p:sp>
+        <p:nvSpPr>
+          <p:cNvPr id="6" name="Shape 3"/>
+          <p:cNvSpPr/>
+          <p:nvPr/>
+        </p:nvSpPr>
+        <p:spPr>
+          <a:xfrm>
+            <a:off x="594360" y="1856232"/>
+            <a:ext cx="3520440" cy="3557016"/>
+          </a:xfrm>
+          <a:prstGeom prst="rect">
+            <a:avLst/>
+          </a:prstGeom>
+          <a:solidFill>
+            <a:srgbClr val="FFFFFF"/>
+          </a:solidFill>
+          <a:ln w="12700">
+            <a:solidFill>
+              <a:srgbClr val="FFFFFF">
+                <a:alpha val="0"/>
+              </a:srgbClr>
+            </a:solidFill>
+            <a:prstDash val="solid"/>
+          </a:ln>
+        </p:spPr>
+      </p:sp>
+      <p:sp>
+        <p:nvSpPr>
+          <p:cNvPr id="7" name="Shape 4"/>
+          <p:cNvSpPr/>
+          <p:nvPr/>
+        </p:nvSpPr>
+        <p:spPr>
+          <a:xfrm>
+            <a:off x="594360" y="1856232"/>
+            <a:ext cx="54864" cy="3557016"/>
+          </a:xfrm>
+          <a:prstGeom prst="rect">
+            <a:avLst/>
+          </a:prstGeom>
+          <a:solidFill>
+            <a:srgbClr val="235AF5"/>
+          </a:solidFill>
+          <a:ln w="12700">
+            <a:solidFill>
+              <a:srgbClr val="235AF5">
+                <a:alpha val="0"/>
+              </a:srgbClr>
+            </a:solidFill>
+            <a:prstDash val="solid"/>
+          </a:ln>
+        </p:spPr>
+      </p:sp>
+      <p:sp>
+        <p:nvSpPr>
+          <p:cNvPr id="8" name="Text 5"/>
+          <p:cNvSpPr/>
+          <p:nvPr/>
+        </p:nvSpPr>
+        <p:spPr>
+          <a:xfrm>
+            <a:off x="804672" y="2057400"/>
+            <a:ext cx="3017520" cy="365760"/>
+          </a:xfrm>
+          <a:prstGeom prst="rect">
+            <a:avLst/>
+          </a:prstGeom>
+          <a:noFill/>
+          <a:ln/>
+        </p:spPr>
+        <p:txBody>
+          <a:bodyPr wrap="square" lIns="0" tIns="0" rIns="0" bIns="0" rtlCol="0" anchor="t"/>
+          <a:lstStyle/>
+          <a:p>
+            <a:pPr indent="0" marL="0">
+              <a:buNone/>
+            </a:pPr>
+            <a:r>
+              <a:rPr lang="en-US" sz="1300" b="1" dirty="0">
+                <a:solidFill>
+                  <a:srgbClr val="235AF5"/>
+                </a:solidFill>
+                <a:latin typeface="Aptos" pitchFamily="34" charset="0"/>
+                <a:ea typeface="Aptos" pitchFamily="34" charset="-122"/>
+                <a:cs typeface="Aptos" pitchFamily="34" charset="-120"/>
+              </a:rPr>
+              <a:t>01</a:t>
+            </a:r>
+            <a:endParaRPr lang="en-US" sz="1300" dirty="0"/>
+          </a:p>
+        </p:txBody>
+      </p:sp>
+      <p:sp>
+        <p:nvSpPr>
+          <p:cNvPr id="9" name="Text 6"/>
+          <p:cNvSpPr/>
+          <p:nvPr/>
+        </p:nvSpPr>
+        <p:spPr>
+          <a:xfrm>
+            <a:off x="804672" y="2587752"/>
+            <a:ext cx="3072384" cy="731520"/>
+          </a:xfrm>
+          <a:prstGeom prst="rect">
+            <a:avLst/>
+          </a:prstGeom>
+          <a:noFill/>
+          <a:ln/>
+        </p:spPr>
+        <p:txBody>
+          <a:bodyPr wrap="square" lIns="0" tIns="0" rIns="0" bIns="0" rtlCol="0" anchor="t"/>
+          <a:lstStyle/>
+          <a:p>
+            <a:pPr indent="0" marL="0">
+              <a:buNone/>
+            </a:pPr>
+            <a:r>
+              <a:rPr lang="en-US" sz="2200" b="1" dirty="0">
+                <a:solidFill>
+                  <a:srgbClr val="0D1933"/>
+                </a:solidFill>
+                <a:latin typeface="Aptos" pitchFamily="34" charset="0"/>
+                <a:ea typeface="Aptos" pitchFamily="34" charset="-122"/>
+                <a:cs typeface="Aptos" pitchFamily="34" charset="-120"/>
+              </a:rPr>
+              <a:t>Archive an incorrect row</a:t>
+            </a:r>
+            <a:endParaRPr lang="en-US" sz="2200" dirty="0"/>
+          </a:p>
+        </p:txBody>
+      </p:sp>
+      <p:sp>
+        <p:nvSpPr>
+          <p:cNvPr id="10" name="Text 7"/>
+          <p:cNvSpPr/>
+          <p:nvPr/>
+        </p:nvSpPr>
+        <p:spPr>
+          <a:xfrm>
+            <a:off x="804672" y="3465576"/>
+            <a:ext cx="3035808" cy="1673352"/>
+          </a:xfrm>
+          <a:prstGeom prst="rect">
+            <a:avLst/>
+          </a:prstGeom>
+          <a:noFill/>
+          <a:ln/>
+        </p:spPr>
+        <p:txBody>
+          <a:bodyPr wrap="square" lIns="0" tIns="0" rIns="0" bIns="0" rtlCol="0" anchor="t"/>
+          <a:lstStyle/>
+          <a:p>
+            <a:pPr indent="0" marL="0">
+              <a:buNone/>
+            </a:pPr>
+            <a:r>
+              <a:rPr lang="en-US" sz="1800" dirty="0">
+                <a:solidFill>
+                  <a:srgbClr val="172641"/>
+                </a:solidFill>
+                <a:latin typeface="Aptos" pitchFamily="34" charset="0"/>
+                <a:ea typeface="Aptos" pitchFamily="34" charset="-122"/>
+                <a:cs typeface="Aptos" pitchFamily="34" charset="-120"/>
+              </a:rPr>
+              <a:t>Open Archive or merge requirement. Choose archive, explain why and confirm. The original stays in Archived requirements.</a:t>
+            </a:r>
+            <a:endParaRPr lang="en-US" sz="1800" dirty="0"/>
+          </a:p>
+        </p:txBody>
+      </p:sp>
+      <p:sp>
+        <p:nvSpPr>
+          <p:cNvPr id="11" name="Shape 8"/>
+          <p:cNvSpPr/>
+          <p:nvPr/>
+        </p:nvSpPr>
+        <p:spPr>
+          <a:xfrm>
+            <a:off x="4343400" y="1856232"/>
+            <a:ext cx="3520440" cy="3557016"/>
+          </a:xfrm>
+          <a:prstGeom prst="rect">
+            <a:avLst/>
+          </a:prstGeom>
+          <a:solidFill>
+            <a:srgbClr val="FFFFFF"/>
+          </a:solidFill>
+          <a:ln w="12700">
+            <a:solidFill>
+              <a:srgbClr val="FFFFFF">
+                <a:alpha val="0"/>
+              </a:srgbClr>
+            </a:solidFill>
+            <a:prstDash val="solid"/>
+          </a:ln>
+        </p:spPr>
+      </p:sp>
+      <p:sp>
+        <p:nvSpPr>
+          <p:cNvPr id="12" name="Shape 9"/>
+          <p:cNvSpPr/>
+          <p:nvPr/>
+        </p:nvSpPr>
+        <p:spPr>
+          <a:xfrm>
+            <a:off x="4343400" y="1856232"/>
+            <a:ext cx="54864" cy="3557016"/>
+          </a:xfrm>
+          <a:prstGeom prst="rect">
+            <a:avLst/>
+          </a:prstGeom>
+          <a:solidFill>
+            <a:srgbClr val="F2B337"/>
+          </a:solidFill>
+          <a:ln w="12700">
+            <a:solidFill>
+              <a:srgbClr val="F2B337">
+                <a:alpha val="0"/>
+              </a:srgbClr>
+            </a:solidFill>
+            <a:prstDash val="solid"/>
+          </a:ln>
+        </p:spPr>
+      </p:sp>
+      <p:sp>
+        <p:nvSpPr>
+          <p:cNvPr id="13" name="Text 10"/>
+          <p:cNvSpPr/>
+          <p:nvPr/>
+        </p:nvSpPr>
+        <p:spPr>
+          <a:xfrm>
+            <a:off x="4553712" y="2057400"/>
+            <a:ext cx="3017520" cy="365760"/>
+          </a:xfrm>
+          <a:prstGeom prst="rect">
+            <a:avLst/>
+          </a:prstGeom>
+          <a:noFill/>
+          <a:ln/>
+        </p:spPr>
+        <p:txBody>
+          <a:bodyPr wrap="square" lIns="0" tIns="0" rIns="0" bIns="0" rtlCol="0" anchor="t"/>
+          <a:lstStyle/>
+          <a:p>
+            <a:pPr indent="0" marL="0">
+              <a:buNone/>
+            </a:pPr>
+            <a:r>
+              <a:rPr lang="en-US" sz="1300" b="1" dirty="0">
+                <a:solidFill>
+                  <a:srgbClr val="235AF5"/>
+                </a:solidFill>
+                <a:latin typeface="Aptos" pitchFamily="34" charset="0"/>
+                <a:ea typeface="Aptos" pitchFamily="34" charset="-122"/>
+                <a:cs typeface="Aptos" pitchFamily="34" charset="-120"/>
+              </a:rPr>
+              <a:t>02</a:t>
+            </a:r>
+            <a:endParaRPr lang="en-US" sz="1300" dirty="0"/>
+          </a:p>
+        </p:txBody>
+      </p:sp>
+      <p:sp>
+        <p:nvSpPr>
+          <p:cNvPr id="14" name="Text 11"/>
+          <p:cNvSpPr/>
+          <p:nvPr/>
+        </p:nvSpPr>
+        <p:spPr>
+          <a:xfrm>
+            <a:off x="4553712" y="2587752"/>
+            <a:ext cx="3072384" cy="731520"/>
+          </a:xfrm>
+          <a:prstGeom prst="rect">
+            <a:avLst/>
+          </a:prstGeom>
+          <a:noFill/>
+          <a:ln/>
+        </p:spPr>
+        <p:txBody>
+          <a:bodyPr wrap="square" lIns="0" tIns="0" rIns="0" bIns="0" rtlCol="0" anchor="t"/>
+          <a:lstStyle/>
+          <a:p>
+            <a:pPr indent="0" marL="0">
+              <a:buNone/>
+            </a:pPr>
+            <a:r>
+              <a:rPr lang="en-US" sz="2200" b="1" dirty="0">
+                <a:solidFill>
+                  <a:srgbClr val="0D1933"/>
+                </a:solidFill>
+                <a:latin typeface="Aptos" pitchFamily="34" charset="0"/>
+                <a:ea typeface="Aptos" pitchFamily="34" charset="-122"/>
+                <a:cs typeface="Aptos" pitchFamily="34" charset="-120"/>
+              </a:rPr>
+              <a:t>Merge duplicate requirements</a:t>
+            </a:r>
+            <a:endParaRPr lang="en-US" sz="2200" dirty="0"/>
+          </a:p>
+        </p:txBody>
+      </p:sp>
+      <p:sp>
+        <p:nvSpPr>
+          <p:cNvPr id="15" name="Text 12"/>
+          <p:cNvSpPr/>
+          <p:nvPr/>
+        </p:nvSpPr>
+        <p:spPr>
+          <a:xfrm>
+            <a:off x="4553712" y="3465576"/>
+            <a:ext cx="3035808" cy="1673352"/>
+          </a:xfrm>
+          <a:prstGeom prst="rect">
+            <a:avLst/>
+          </a:prstGeom>
+          <a:noFill/>
+          <a:ln/>
+        </p:spPr>
+        <p:txBody>
+          <a:bodyPr wrap="square" lIns="0" tIns="0" rIns="0" bIns="0" rtlCol="0" anchor="t"/>
+          <a:lstStyle/>
+          <a:p>
+            <a:pPr indent="0" marL="0">
+              <a:buNone/>
+            </a:pPr>
+            <a:r>
+              <a:rPr lang="en-US" sz="1800" dirty="0">
+                <a:solidFill>
+                  <a:srgbClr val="172641"/>
+                </a:solidFill>
+                <a:latin typeface="Aptos" pitchFamily="34" charset="0"/>
+                <a:ea typeface="Aptos" pitchFamily="34" charset="-122"/>
+                <a:cs typeface="Aptos" pitchFamily="34" charset="-120"/>
+              </a:rPr>
+              <a:t>Choose an active target in the same pursuit and review the combined wording. Both citations are preserved; the source is archived.</a:t>
+            </a:r>
+            <a:endParaRPr lang="en-US" sz="1800" dirty="0"/>
+          </a:p>
+        </p:txBody>
+      </p:sp>
+      <p:sp>
+        <p:nvSpPr>
+          <p:cNvPr id="16" name="Shape 13"/>
+          <p:cNvSpPr/>
+          <p:nvPr/>
+        </p:nvSpPr>
+        <p:spPr>
+          <a:xfrm>
+            <a:off x="8092440" y="1856232"/>
+            <a:ext cx="3520440" cy="3557016"/>
+          </a:xfrm>
+          <a:prstGeom prst="rect">
+            <a:avLst/>
+          </a:prstGeom>
+          <a:solidFill>
+            <a:srgbClr val="FFFFFF"/>
+          </a:solidFill>
+          <a:ln w="12700">
+            <a:solidFill>
+              <a:srgbClr val="FFFFFF">
+                <a:alpha val="0"/>
+              </a:srgbClr>
+            </a:solidFill>
+            <a:prstDash val="solid"/>
+          </a:ln>
+        </p:spPr>
+      </p:sp>
+      <p:sp>
+        <p:nvSpPr>
+          <p:cNvPr id="17" name="Shape 14"/>
+          <p:cNvSpPr/>
+          <p:nvPr/>
+        </p:nvSpPr>
+        <p:spPr>
+          <a:xfrm>
+            <a:off x="8092440" y="1856232"/>
+            <a:ext cx="54864" cy="3557016"/>
+          </a:xfrm>
+          <a:prstGeom prst="rect">
+            <a:avLst/>
+          </a:prstGeom>
+          <a:solidFill>
+            <a:srgbClr val="235AF5"/>
+          </a:solidFill>
+          <a:ln w="12700">
+            <a:solidFill>
+              <a:srgbClr val="235AF5">
+                <a:alpha val="0"/>
+              </a:srgbClr>
+            </a:solidFill>
+            <a:prstDash val="solid"/>
+          </a:ln>
+        </p:spPr>
+      </p:sp>
+      <p:sp>
+        <p:nvSpPr>
+          <p:cNvPr id="18" name="Text 15"/>
+          <p:cNvSpPr/>
+          <p:nvPr/>
+        </p:nvSpPr>
+        <p:spPr>
+          <a:xfrm>
+            <a:off x="8302752" y="2057400"/>
+            <a:ext cx="3017520" cy="365760"/>
+          </a:xfrm>
+          <a:prstGeom prst="rect">
+            <a:avLst/>
+          </a:prstGeom>
+          <a:noFill/>
+          <a:ln/>
+        </p:spPr>
+        <p:txBody>
+          <a:bodyPr wrap="square" lIns="0" tIns="0" rIns="0" bIns="0" rtlCol="0" anchor="t"/>
+          <a:lstStyle/>
+          <a:p>
+            <a:pPr indent="0" marL="0">
+              <a:buNone/>
+            </a:pPr>
+            <a:r>
+              <a:rPr lang="en-US" sz="1300" b="1" dirty="0">
+                <a:solidFill>
+                  <a:srgbClr val="235AF5"/>
+                </a:solidFill>
+                <a:latin typeface="Aptos" pitchFamily="34" charset="0"/>
+                <a:ea typeface="Aptos" pitchFamily="34" charset="-122"/>
+                <a:cs typeface="Aptos" pitchFamily="34" charset="-120"/>
+              </a:rPr>
+              <a:t>03</a:t>
+            </a:r>
+            <a:endParaRPr lang="en-US" sz="1300" dirty="0"/>
+          </a:p>
+        </p:txBody>
+      </p:sp>
+      <p:sp>
+        <p:nvSpPr>
+          <p:cNvPr id="19" name="Text 16"/>
+          <p:cNvSpPr/>
+          <p:nvPr/>
+        </p:nvSpPr>
+        <p:spPr>
+          <a:xfrm>
+            <a:off x="8302752" y="2587752"/>
+            <a:ext cx="3072384" cy="731520"/>
+          </a:xfrm>
+          <a:prstGeom prst="rect">
+            <a:avLst/>
+          </a:prstGeom>
+          <a:noFill/>
+          <a:ln/>
+        </p:spPr>
+        <p:txBody>
+          <a:bodyPr wrap="square" lIns="0" tIns="0" rIns="0" bIns="0" rtlCol="0" anchor="t"/>
+          <a:lstStyle/>
+          <a:p>
+            <a:pPr indent="0" marL="0">
+              <a:buNone/>
+            </a:pPr>
+            <a:r>
+              <a:rPr lang="en-US" sz="2200" b="1" dirty="0">
+                <a:solidFill>
+                  <a:srgbClr val="0D1933"/>
+                </a:solidFill>
+                <a:latin typeface="Aptos" pitchFamily="34" charset="0"/>
+                <a:ea typeface="Aptos" pitchFamily="34" charset="-122"/>
+                <a:cs typeface="Aptos" pitchFamily="34" charset="-120"/>
+              </a:rPr>
+              <a:t>Restore for another review</a:t>
+            </a:r>
+            <a:endParaRPr lang="en-US" sz="2200" dirty="0"/>
+          </a:p>
+        </p:txBody>
+      </p:sp>
+      <p:sp>
+        <p:nvSpPr>
+          <p:cNvPr id="20" name="Text 17"/>
+          <p:cNvSpPr/>
+          <p:nvPr/>
+        </p:nvSpPr>
+        <p:spPr>
+          <a:xfrm>
+            <a:off x="8302752" y="3465576"/>
+            <a:ext cx="3035808" cy="1673352"/>
+          </a:xfrm>
+          <a:prstGeom prst="rect">
+            <a:avLst/>
+          </a:prstGeom>
+          <a:noFill/>
+          <a:ln/>
+        </p:spPr>
+        <p:txBody>
+          <a:bodyPr wrap="square" lIns="0" tIns="0" rIns="0" bIns="0" rtlCol="0" anchor="t"/>
+          <a:lstStyle/>
+          <a:p>
+            <a:pPr indent="0" marL="0">
+              <a:buNone/>
+            </a:pPr>
+            <a:r>
+              <a:rPr lang="en-US" sz="1800" dirty="0">
+                <a:solidFill>
+                  <a:srgbClr val="172641"/>
+                </a:solidFill>
+                <a:latin typeface="Aptos" pitchFamily="34" charset="0"/>
+                <a:ea typeface="Aptos" pitchFamily="34" charset="-122"/>
+                <a:cs typeface="Aptos" pitchFamily="34" charset="-120"/>
+              </a:rPr>
+              <a:t>Open an archived row and choose Restore requirement. The original returns as needs review. Review any merged target separately.</a:t>
+            </a:r>
+            <a:endParaRPr lang="en-US" sz="1800" dirty="0"/>
+          </a:p>
+        </p:txBody>
+      </p:sp>
+      <p:sp>
+        <p:nvSpPr>
+          <p:cNvPr id="21" name="Shape 18"/>
+          <p:cNvSpPr/>
+          <p:nvPr/>
+        </p:nvSpPr>
+        <p:spPr>
+          <a:xfrm>
+            <a:off x="594360" y="5650992"/>
+            <a:ext cx="11018520" cy="576072"/>
+          </a:xfrm>
+          <a:prstGeom prst="rect">
+            <a:avLst/>
+          </a:prstGeom>
+          <a:solidFill>
+            <a:srgbClr val="0D1933"/>
+          </a:solidFill>
+          <a:ln w="12700">
+            <a:solidFill>
+              <a:srgbClr val="0D1933">
+                <a:alpha val="0"/>
+              </a:srgbClr>
+            </a:solidFill>
+            <a:prstDash val="solid"/>
+          </a:ln>
+        </p:spPr>
+      </p:sp>
+      <p:sp>
+        <p:nvSpPr>
+          <p:cNvPr id="22" name="Text 19"/>
+          <p:cNvSpPr/>
+          <p:nvPr/>
+        </p:nvSpPr>
+        <p:spPr>
+          <a:xfrm>
+            <a:off x="777240" y="5779008"/>
+            <a:ext cx="10607040" cy="374904"/>
+          </a:xfrm>
+          <a:prstGeom prst="rect">
+            <a:avLst/>
+          </a:prstGeom>
+          <a:noFill/>
+          <a:ln/>
+        </p:spPr>
+        <p:txBody>
+          <a:bodyPr wrap="square" lIns="0" tIns="0" rIns="0" bIns="0" rtlCol="0" anchor="t"/>
+          <a:lstStyle/>
+          <a:p>
+            <a:pPr indent="0" marL="0">
+              <a:buNone/>
+            </a:pPr>
+            <a:r>
+              <a:rPr lang="en-US" sz="1400" dirty="0">
+                <a:solidFill>
+                  <a:srgbClr val="FFFFFF"/>
+                </a:solidFill>
+                <a:latin typeface="Aptos" pitchFamily="34" charset="0"/>
+                <a:ea typeface="Aptos" pitchFamily="34" charset="-122"/>
+                <a:cs typeface="Aptos" pitchFamily="34" charset="-120"/>
+              </a:rPr>
+              <a:t>Corrections require fresh sign-off and approval. Archiving is not a buyer waiver.</a:t>
+            </a:r>
+            <a:endParaRPr lang="en-US" sz="1400" dirty="0"/>
+          </a:p>
+        </p:txBody>
+      </p:sp>
+      <p:sp>
+        <p:nvSpPr>
+          <p:cNvPr id="23" name="Text 20"/>
+          <p:cNvSpPr/>
+          <p:nvPr/>
+        </p:nvSpPr>
+        <p:spPr>
+          <a:xfrm>
+            <a:off x="594360" y="6510528"/>
+            <a:ext cx="9144000" cy="182880"/>
+          </a:xfrm>
+          <a:prstGeom prst="rect">
+            <a:avLst/>
+          </a:prstGeom>
+          <a:noFill/>
+          <a:ln/>
+        </p:spPr>
+        <p:txBody>
+          <a:bodyPr wrap="square" lIns="0" tIns="0" rIns="0" bIns="0" rtlCol="0" anchor="t"/>
+          <a:lstStyle/>
+          <a:p>
+            <a:pPr indent="0" marL="0">
+              <a:buNone/>
+            </a:pPr>
+            <a:r>
+              <a:rPr lang="en-US" sz="900" dirty="0">
+                <a:solidFill>
+                  <a:srgbClr val="506178"/>
+                </a:solidFill>
+                <a:latin typeface="Aptos" pitchFamily="34" charset="0"/>
+                <a:ea typeface="Aptos" pitchFamily="34" charset="-122"/>
+                <a:cs typeface="Aptos" pitchFamily="34" charset="-120"/>
+              </a:rPr>
+              <a:t>BidXchange  /  HOW TO USE THE APP</a:t>
+            </a:r>
+            <a:endParaRPr lang="en-US" sz="900" dirty="0"/>
+          </a:p>
+        </p:txBody>
+      </p:sp>
+      <p:sp>
+        <p:nvSpPr>
+          <p:cNvPr id="24" name="Text 21"/>
+          <p:cNvSpPr/>
+          <p:nvPr/>
+        </p:nvSpPr>
+        <p:spPr>
+          <a:xfrm>
+            <a:off x="11000232" y="6473952"/>
+            <a:ext cx="594360" cy="246888"/>
+          </a:xfrm>
+          <a:prstGeom prst="rect">
+            <a:avLst/>
+          </a:prstGeom>
+          <a:noFill/>
+          <a:ln/>
+        </p:spPr>
+        <p:txBody>
+          <a:bodyPr wrap="square" lIns="0" tIns="0" rIns="0" bIns="0" rtlCol="0" anchor="t"/>
+          <a:lstStyle/>
+          <a:p>
+            <a:pPr algn="r" indent="0" marL="0">
+              <a:buNone/>
+            </a:pPr>
+            <a:r>
+              <a:rPr lang="en-US" sz="1100" dirty="0">
+                <a:solidFill>
+                  <a:srgbClr val="506178"/>
+                </a:solidFill>
+                <a:latin typeface="Aptos" pitchFamily="34" charset="0"/>
+                <a:ea typeface="Aptos" pitchFamily="34" charset="-122"/>
+                <a:cs typeface="Aptos" pitchFamily="34" charset="-120"/>
+              </a:rPr>
+              <a:t>27</a:t>
+            </a:r>
+            <a:endParaRPr lang="en-US" sz="1100" dirty="0"/>
+          </a:p>
+        </p:txBody>
+      </p:sp>
+    </p:spTree>
+  </p:cSld>
+  <p:clrMapOvr>
+    <a:masterClrMapping/>
+  </p:clrMapOvr>
+</p:sld>
+</file>
+
 <file path=ppt/slides/slide3.xml><?xml version="1.0" encoding="utf-8"?>
 <p:sld xmlns:a="http://schemas.openxmlformats.org/drawingml/2006/main" xmlns:r="http://schemas.openxmlformats.org/officeDocument/2006/relationships" xmlns:p="http://schemas.openxmlformats.org/presentationml/2006/main">
   <p:cSld name="Slide 3">

</xml_diff>